<commit_message>
update docs, removing waste, bug fix, add tests
</commit_message>
<xml_diff>
--- a/Task 9/Presentation/DoVeSo_BaoCao_Lab3.pptx
+++ b/Task 9/Presentation/DoVeSo_BaoCao_Lab3.pptx
@@ -11,26 +11,26 @@
     <p:sldId id="259" r:id="rId5"/>
     <p:sldId id="260" r:id="rId6"/>
     <p:sldId id="261" r:id="rId7"/>
-    <p:sldId id="263" r:id="rId8"/>
-    <p:sldId id="264" r:id="rId9"/>
-    <p:sldId id="265" r:id="rId10"/>
-    <p:sldId id="266" r:id="rId11"/>
-    <p:sldId id="267" r:id="rId12"/>
-    <p:sldId id="268" r:id="rId13"/>
-    <p:sldId id="269" r:id="rId14"/>
-    <p:sldId id="270" r:id="rId15"/>
-    <p:sldId id="271" r:id="rId16"/>
-    <p:sldId id="272" r:id="rId17"/>
-    <p:sldId id="273" r:id="rId18"/>
-    <p:sldId id="274" r:id="rId19"/>
-    <p:sldId id="275" r:id="rId20"/>
-    <p:sldId id="276" r:id="rId21"/>
-    <p:sldId id="277" r:id="rId22"/>
-    <p:sldId id="278" r:id="rId23"/>
-    <p:sldId id="279" r:id="rId24"/>
-    <p:sldId id="280" r:id="rId25"/>
-    <p:sldId id="281" r:id="rId26"/>
-    <p:sldId id="282" r:id="rId27"/>
+    <p:sldId id="262" r:id="rId8"/>
+    <p:sldId id="263" r:id="rId9"/>
+    <p:sldId id="264" r:id="rId10"/>
+    <p:sldId id="265" r:id="rId11"/>
+    <p:sldId id="266" r:id="rId12"/>
+    <p:sldId id="267" r:id="rId13"/>
+    <p:sldId id="268" r:id="rId14"/>
+    <p:sldId id="269" r:id="rId15"/>
+    <p:sldId id="270" r:id="rId16"/>
+    <p:sldId id="271" r:id="rId17"/>
+    <p:sldId id="272" r:id="rId18"/>
+    <p:sldId id="273" r:id="rId19"/>
+    <p:sldId id="274" r:id="rId20"/>
+    <p:sldId id="275" r:id="rId21"/>
+    <p:sldId id="276" r:id="rId22"/>
+    <p:sldId id="277" r:id="rId23"/>
+    <p:sldId id="278" r:id="rId24"/>
+    <p:sldId id="279" r:id="rId25"/>
+    <p:sldId id="280" r:id="rId26"/>
+    <p:sldId id="281" r:id="rId27"/>
   </p:sldIdLst>
   <p:sldSz cx="12192000" cy="6858000"/>
   <p:notesSz cx="6858000" cy="9144000"/>
@@ -327,7 +327,7 @@
           <a:p>
             <a:fld id="{5BCAD085-E8A6-8845-BD4E-CB4CCA059FC4}" type="datetimeFigureOut">
               <a:rPr lang="en-US" smtClean="0"/>
-              <a:t>7/31/2026</a:t>
+              <a:t>8/1/2026</a:t>
             </a:fld>
             <a:endParaRPr lang="en-US"/>
           </a:p>
@@ -495,7 +495,7 @@
           <a:p>
             <a:fld id="{5BCAD085-E8A6-8845-BD4E-CB4CCA059FC4}" type="datetimeFigureOut">
               <a:rPr lang="en-US" smtClean="0"/>
-              <a:t>7/31/2026</a:t>
+              <a:t>8/1/2026</a:t>
             </a:fld>
             <a:endParaRPr lang="en-US"/>
           </a:p>
@@ -673,7 +673,7 @@
           <a:p>
             <a:fld id="{5BCAD085-E8A6-8845-BD4E-CB4CCA059FC4}" type="datetimeFigureOut">
               <a:rPr lang="en-US" smtClean="0"/>
-              <a:t>7/31/2026</a:t>
+              <a:t>8/1/2026</a:t>
             </a:fld>
             <a:endParaRPr lang="en-US"/>
           </a:p>
@@ -841,7 +841,7 @@
           <a:p>
             <a:fld id="{5BCAD085-E8A6-8845-BD4E-CB4CCA059FC4}" type="datetimeFigureOut">
               <a:rPr lang="en-US" smtClean="0"/>
-              <a:t>7/31/2026</a:t>
+              <a:t>8/1/2026</a:t>
             </a:fld>
             <a:endParaRPr lang="en-US"/>
           </a:p>
@@ -1086,7 +1086,7 @@
           <a:p>
             <a:fld id="{5BCAD085-E8A6-8845-BD4E-CB4CCA059FC4}" type="datetimeFigureOut">
               <a:rPr lang="en-US" smtClean="0"/>
-              <a:t>7/31/2026</a:t>
+              <a:t>8/1/2026</a:t>
             </a:fld>
             <a:endParaRPr lang="en-US"/>
           </a:p>
@@ -1371,7 +1371,7 @@
           <a:p>
             <a:fld id="{5BCAD085-E8A6-8845-BD4E-CB4CCA059FC4}" type="datetimeFigureOut">
               <a:rPr lang="en-US" smtClean="0"/>
-              <a:t>7/31/2026</a:t>
+              <a:t>8/1/2026</a:t>
             </a:fld>
             <a:endParaRPr lang="en-US"/>
           </a:p>
@@ -1790,7 +1790,7 @@
           <a:p>
             <a:fld id="{5BCAD085-E8A6-8845-BD4E-CB4CCA059FC4}" type="datetimeFigureOut">
               <a:rPr lang="en-US" smtClean="0"/>
-              <a:t>7/31/2026</a:t>
+              <a:t>8/1/2026</a:t>
             </a:fld>
             <a:endParaRPr lang="en-US"/>
           </a:p>
@@ -1907,7 +1907,7 @@
           <a:p>
             <a:fld id="{5BCAD085-E8A6-8845-BD4E-CB4CCA059FC4}" type="datetimeFigureOut">
               <a:rPr lang="en-US" smtClean="0"/>
-              <a:t>7/31/2026</a:t>
+              <a:t>8/1/2026</a:t>
             </a:fld>
             <a:endParaRPr lang="en-US"/>
           </a:p>
@@ -2002,7 +2002,7 @@
           <a:p>
             <a:fld id="{5BCAD085-E8A6-8845-BD4E-CB4CCA059FC4}" type="datetimeFigureOut">
               <a:rPr lang="en-US" smtClean="0"/>
-              <a:t>7/31/2026</a:t>
+              <a:t>8/1/2026</a:t>
             </a:fld>
             <a:endParaRPr lang="en-US"/>
           </a:p>
@@ -2277,7 +2277,7 @@
           <a:p>
             <a:fld id="{5BCAD085-E8A6-8845-BD4E-CB4CCA059FC4}" type="datetimeFigureOut">
               <a:rPr lang="en-US" smtClean="0"/>
-              <a:t>7/31/2026</a:t>
+              <a:t>8/1/2026</a:t>
             </a:fld>
             <a:endParaRPr lang="en-US"/>
           </a:p>
@@ -2529,7 +2529,7 @@
           <a:p>
             <a:fld id="{5BCAD085-E8A6-8845-BD4E-CB4CCA059FC4}" type="datetimeFigureOut">
               <a:rPr lang="en-US" smtClean="0"/>
-              <a:t>7/31/2026</a:t>
+              <a:t>8/1/2026</a:t>
             </a:fld>
             <a:endParaRPr lang="en-US"/>
           </a:p>
@@ -2740,7 +2740,7 @@
           <a:p>
             <a:fld id="{5BCAD085-E8A6-8845-BD4E-CB4CCA059FC4}" type="datetimeFigureOut">
               <a:rPr lang="en-US" smtClean="0"/>
-              <a:t>7/31/2026</a:t>
+              <a:t>8/1/2026</a:t>
             </a:fld>
             <a:endParaRPr lang="en-US"/>
           </a:p>
@@ -3363,7 +3363,7 @@
         <p:spPr>
           <a:xfrm>
             <a:off x="914400" y="2971800"/>
-            <a:ext cx="8961120" cy="345864"/>
+            <a:ext cx="8961120" cy="731520"/>
           </a:xfrm>
           <a:prstGeom prst="rect">
             <a:avLst/>
@@ -3391,209 +3391,14 @@
               </a:defRPr>
             </a:pPr>
             <a:r>
-              <a:rPr sz="2300" b="0" dirty="0" err="1">
+              <a:rPr sz="2300" b="0">
                 <a:solidFill>
                   <a:srgbClr val="E5E7EB"/>
                 </a:solidFill>
                 <a:latin typeface="Arial"/>
               </a:rPr>
-              <a:t>Hệ</a:t>
-            </a:r>
-            <a:r>
-              <a:rPr sz="2300" b="0" dirty="0">
-                <a:solidFill>
-                  <a:srgbClr val="E5E7EB"/>
-                </a:solidFill>
-                <a:latin typeface="Arial"/>
-              </a:rPr>
-              <a:t> </a:t>
-            </a:r>
-            <a:r>
-              <a:rPr sz="2300" b="0" dirty="0" err="1">
-                <a:solidFill>
-                  <a:srgbClr val="E5E7EB"/>
-                </a:solidFill>
-                <a:latin typeface="Arial"/>
-              </a:rPr>
-              <a:t>thống</a:t>
-            </a:r>
-            <a:r>
-              <a:rPr sz="2300" b="0" dirty="0">
-                <a:solidFill>
-                  <a:srgbClr val="E5E7EB"/>
-                </a:solidFill>
-                <a:latin typeface="Arial"/>
-              </a:rPr>
-              <a:t> </a:t>
-            </a:r>
-            <a:r>
-              <a:rPr sz="2300" b="0" dirty="0" err="1">
-                <a:solidFill>
-                  <a:srgbClr val="E5E7EB"/>
-                </a:solidFill>
-                <a:latin typeface="Arial"/>
-              </a:rPr>
-              <a:t>tra</a:t>
-            </a:r>
-            <a:r>
-              <a:rPr sz="2300" b="0" dirty="0">
-                <a:solidFill>
-                  <a:srgbClr val="E5E7EB"/>
-                </a:solidFill>
-                <a:latin typeface="Arial"/>
-              </a:rPr>
-              <a:t> </a:t>
-            </a:r>
-            <a:r>
-              <a:rPr sz="2300" b="0" dirty="0" err="1">
-                <a:solidFill>
-                  <a:srgbClr val="E5E7EB"/>
-                </a:solidFill>
-                <a:latin typeface="Arial"/>
-              </a:rPr>
-              <a:t>cứu</a:t>
-            </a:r>
-            <a:r>
-              <a:rPr sz="2300" b="0" dirty="0">
-                <a:solidFill>
-                  <a:srgbClr val="E5E7EB"/>
-                </a:solidFill>
-                <a:latin typeface="Arial"/>
-              </a:rPr>
-              <a:t> </a:t>
-            </a:r>
-            <a:r>
-              <a:rPr sz="2300" b="0" dirty="0" err="1">
-                <a:solidFill>
-                  <a:srgbClr val="E5E7EB"/>
-                </a:solidFill>
-                <a:latin typeface="Arial"/>
-              </a:rPr>
-              <a:t>và</a:t>
-            </a:r>
-            <a:r>
-              <a:rPr sz="2300" b="0" dirty="0">
-                <a:solidFill>
-                  <a:srgbClr val="E5E7EB"/>
-                </a:solidFill>
-                <a:latin typeface="Arial"/>
-              </a:rPr>
-              <a:t> </a:t>
-            </a:r>
-            <a:r>
-              <a:rPr sz="2300" b="0" dirty="0" err="1">
-                <a:solidFill>
-                  <a:srgbClr val="E5E7EB"/>
-                </a:solidFill>
-                <a:latin typeface="Arial"/>
-              </a:rPr>
-              <a:t>quản</a:t>
-            </a:r>
-            <a:r>
-              <a:rPr sz="2300" b="0" dirty="0">
-                <a:solidFill>
-                  <a:srgbClr val="E5E7EB"/>
-                </a:solidFill>
-                <a:latin typeface="Arial"/>
-              </a:rPr>
-              <a:t> </a:t>
-            </a:r>
-            <a:r>
-              <a:rPr sz="2300" b="0" dirty="0" err="1">
-                <a:solidFill>
-                  <a:srgbClr val="E5E7EB"/>
-                </a:solidFill>
-                <a:latin typeface="Arial"/>
-              </a:rPr>
-              <a:t>lý</a:t>
-            </a:r>
-            <a:r>
-              <a:rPr sz="2300" b="0" dirty="0">
-                <a:solidFill>
-                  <a:srgbClr val="E5E7EB"/>
-                </a:solidFill>
-                <a:latin typeface="Arial"/>
-              </a:rPr>
-              <a:t> </a:t>
-            </a:r>
-            <a:r>
-              <a:rPr sz="2300" b="0" dirty="0" err="1">
-                <a:solidFill>
-                  <a:srgbClr val="E5E7EB"/>
-                </a:solidFill>
-                <a:latin typeface="Arial"/>
-              </a:rPr>
-              <a:t>kết</a:t>
-            </a:r>
-            <a:r>
-              <a:rPr sz="2300" b="0" dirty="0">
-                <a:solidFill>
-                  <a:srgbClr val="E5E7EB"/>
-                </a:solidFill>
-                <a:latin typeface="Arial"/>
-              </a:rPr>
-              <a:t> </a:t>
-            </a:r>
-            <a:r>
-              <a:rPr sz="2300" b="0" dirty="0" err="1">
-                <a:solidFill>
-                  <a:srgbClr val="E5E7EB"/>
-                </a:solidFill>
-                <a:latin typeface="Arial"/>
-              </a:rPr>
-              <a:t>quả</a:t>
-            </a:r>
-            <a:r>
-              <a:rPr sz="2300" b="0" dirty="0">
-                <a:solidFill>
-                  <a:srgbClr val="E5E7EB"/>
-                </a:solidFill>
-                <a:latin typeface="Arial"/>
-              </a:rPr>
-              <a:t> </a:t>
-            </a:r>
-            <a:r>
-              <a:rPr sz="2300" b="0" dirty="0" err="1">
-                <a:solidFill>
-                  <a:srgbClr val="E5E7EB"/>
-                </a:solidFill>
-                <a:latin typeface="Arial"/>
-              </a:rPr>
-              <a:t>xổ</a:t>
-            </a:r>
-            <a:r>
-              <a:rPr sz="2300" b="0" dirty="0">
-                <a:solidFill>
-                  <a:srgbClr val="E5E7EB"/>
-                </a:solidFill>
-                <a:latin typeface="Arial"/>
-              </a:rPr>
-              <a:t> </a:t>
-            </a:r>
-            <a:r>
-              <a:rPr sz="2300" b="0" dirty="0" err="1">
-                <a:solidFill>
-                  <a:srgbClr val="E5E7EB"/>
-                </a:solidFill>
-                <a:latin typeface="Arial"/>
-              </a:rPr>
-              <a:t>s</a:t>
-            </a:r>
-            <a:r>
-              <a:rPr lang="en-US" sz="2300" b="0" dirty="0" err="1">
-                <a:solidFill>
-                  <a:srgbClr val="E5E7EB"/>
-                </a:solidFill>
-                <a:latin typeface="Arial"/>
-              </a:rPr>
-              <a:t>ố</a:t>
-            </a:r>
-            <a:endParaRPr sz="2300" b="0" dirty="0">
-              <a:solidFill>
-                <a:srgbClr val="E5E7EB"/>
-              </a:solidFill>
-              <a:latin typeface="Arial"/>
-            </a:endParaRPr>
+              <a:t>Hệ thống tra cứu và quản lý kết quả xổ số kiến thiết</a:t>
+            </a:r>
           </a:p>
         </p:txBody>
       </p:sp>
@@ -4075,7 +3880,7 @@
                 </a:solidFill>
                 <a:latin typeface="Arial"/>
               </a:rPr>
-              <a:t>11</a:t>
+              <a:t>10</a:t>
             </a:r>
           </a:p>
         </p:txBody>
@@ -4097,11 +3902,11 @@
             </a:avLst>
           </a:prstGeom>
           <a:solidFill>
-            <a:srgbClr val="FFFFFF"/>
+            <a:srgbClr val="E8EDF4"/>
           </a:solidFill>
-          <a:ln w="12700">
+          <a:ln w="17780">
             <a:solidFill>
-              <a:srgbClr val="D9E2EC"/>
+              <a:srgbClr val="B0BEC5"/>
             </a:solidFill>
           </a:ln>
           <a:effectLst/>
@@ -4581,7 +4386,7 @@
                 </a:solidFill>
                 <a:latin typeface="Arial"/>
               </a:rPr>
-              <a:t>12</a:t>
+              <a:t>11</a:t>
             </a:r>
           </a:p>
         </p:txBody>
@@ -4603,11 +4408,11 @@
             </a:avLst>
           </a:prstGeom>
           <a:solidFill>
-            <a:srgbClr val="FFFFFF"/>
+            <a:srgbClr val="E8EDF4"/>
           </a:solidFill>
-          <a:ln w="12700">
+          <a:ln w="17780">
             <a:solidFill>
-              <a:srgbClr val="D9E2EC"/>
+              <a:srgbClr val="B0BEC5"/>
             </a:solidFill>
           </a:ln>
           <a:effectLst/>
@@ -5087,7 +4892,7 @@
                 </a:solidFill>
                 <a:latin typeface="Arial"/>
               </a:rPr>
-              <a:t>13</a:t>
+              <a:t>12</a:t>
             </a:r>
           </a:p>
         </p:txBody>
@@ -6176,7 +5981,7 @@
                 </a:solidFill>
                 <a:latin typeface="Arial"/>
               </a:rPr>
-              <a:t>Giao diện Desktop – Màn hình dò vé số</a:t>
+              <a:t>Giao diện Desktop - Màn hình dò vé số</a:t>
             </a:r>
           </a:p>
         </p:txBody>
@@ -6317,7 +6122,7 @@
                 </a:solidFill>
                 <a:latin typeface="Arial"/>
               </a:rPr>
-              <a:t>14</a:t>
+              <a:t>13</a:t>
             </a:r>
           </a:p>
         </p:txBody>
@@ -6339,13 +6144,11 @@
             </a:avLst>
           </a:prstGeom>
           <a:solidFill>
-            <a:schemeClr val="bg1">
-              <a:lumMod val="85000"/>
-            </a:schemeClr>
+            <a:srgbClr val="E8EDF4"/>
           </a:solidFill>
-          <a:ln w="12700">
+          <a:ln w="17780">
             <a:solidFill>
-              <a:srgbClr val="D9E2EC"/>
+              <a:srgbClr val="B0BEC5"/>
             </a:solidFill>
           </a:ln>
           <a:effectLst/>
@@ -6800,7 +6603,7 @@
                 </a:solidFill>
                 <a:latin typeface="Arial"/>
               </a:rPr>
-              <a:t>15</a:t>
+              <a:t>14</a:t>
             </a:r>
           </a:p>
         </p:txBody>
@@ -6822,13 +6625,11 @@
             </a:avLst>
           </a:prstGeom>
           <a:solidFill>
-            <a:schemeClr val="bg1">
-              <a:lumMod val="85000"/>
-            </a:schemeClr>
+            <a:srgbClr val="E8EDF4"/>
           </a:solidFill>
-          <a:ln w="12700">
+          <a:ln w="17780">
             <a:solidFill>
-              <a:srgbClr val="D9E2EC"/>
+              <a:srgbClr val="B0BEC5"/>
             </a:solidFill>
           </a:ln>
           <a:effectLst/>
@@ -7283,7 +7084,7 @@
                 </a:solidFill>
                 <a:latin typeface="Arial"/>
               </a:rPr>
-              <a:t>16</a:t>
+              <a:t>15</a:t>
             </a:r>
           </a:p>
         </p:txBody>
@@ -7305,13 +7106,11 @@
             </a:avLst>
           </a:prstGeom>
           <a:solidFill>
-            <a:schemeClr val="bg1">
-              <a:lumMod val="85000"/>
-            </a:schemeClr>
+            <a:srgbClr val="E8EDF4"/>
           </a:solidFill>
-          <a:ln w="12700">
+          <a:ln w="17780">
             <a:solidFill>
-              <a:srgbClr val="D9E2EC"/>
+              <a:srgbClr val="B0BEC5"/>
             </a:solidFill>
           </a:ln>
           <a:effectLst/>
@@ -7428,13 +7227,11 @@
             </a:avLst>
           </a:prstGeom>
           <a:solidFill>
-            <a:schemeClr val="bg1">
-              <a:lumMod val="85000"/>
-            </a:schemeClr>
+            <a:srgbClr val="E8EDF4"/>
           </a:solidFill>
-          <a:ln w="12700">
+          <a:ln w="17780">
             <a:solidFill>
-              <a:srgbClr val="D9E2EC"/>
+              <a:srgbClr val="B0BEC5"/>
             </a:solidFill>
           </a:ln>
           <a:effectLst/>
@@ -7551,13 +7348,11 @@
             </a:avLst>
           </a:prstGeom>
           <a:solidFill>
-            <a:schemeClr val="bg1">
-              <a:lumMod val="85000"/>
-            </a:schemeClr>
+            <a:srgbClr val="E8EDF4"/>
           </a:solidFill>
-          <a:ln w="12700">
+          <a:ln w="17780">
             <a:solidFill>
-              <a:srgbClr val="D9E2EC"/>
+              <a:srgbClr val="B0BEC5"/>
             </a:solidFill>
           </a:ln>
           <a:effectLst/>
@@ -7674,13 +7469,11 @@
             </a:avLst>
           </a:prstGeom>
           <a:solidFill>
-            <a:schemeClr val="bg1">
-              <a:lumMod val="85000"/>
-            </a:schemeClr>
+            <a:srgbClr val="E8EDF4"/>
           </a:solidFill>
-          <a:ln w="12700">
+          <a:ln w="17780">
             <a:solidFill>
-              <a:srgbClr val="D9E2EC"/>
+              <a:srgbClr val="B0BEC5"/>
             </a:solidFill>
           </a:ln>
           <a:effectLst/>
@@ -8135,7 +7928,7 @@
                 </a:solidFill>
                 <a:latin typeface="Arial"/>
               </a:rPr>
-              <a:t>17</a:t>
+              <a:t>16</a:t>
             </a:r>
           </a:p>
         </p:txBody>
@@ -8157,13 +7950,11 @@
             </a:avLst>
           </a:prstGeom>
           <a:solidFill>
-            <a:schemeClr val="bg1">
-              <a:lumMod val="85000"/>
-            </a:schemeClr>
+            <a:srgbClr val="E8EDF4"/>
           </a:solidFill>
-          <a:ln w="12700">
+          <a:ln w="17780">
             <a:solidFill>
-              <a:srgbClr val="D9E2EC"/>
+              <a:srgbClr val="B0BEC5"/>
             </a:solidFill>
           </a:ln>
           <a:effectLst/>
@@ -8280,13 +8071,11 @@
             </a:avLst>
           </a:prstGeom>
           <a:solidFill>
-            <a:schemeClr val="bg1">
-              <a:lumMod val="85000"/>
-            </a:schemeClr>
+            <a:srgbClr val="E8EDF4"/>
           </a:solidFill>
-          <a:ln w="12700">
+          <a:ln w="17780">
             <a:solidFill>
-              <a:srgbClr val="D9E2EC"/>
+              <a:srgbClr val="B0BEC5"/>
             </a:solidFill>
           </a:ln>
           <a:effectLst/>
@@ -8403,13 +8192,11 @@
             </a:avLst>
           </a:prstGeom>
           <a:solidFill>
-            <a:schemeClr val="bg1">
-              <a:lumMod val="85000"/>
-            </a:schemeClr>
+            <a:srgbClr val="E8EDF4"/>
           </a:solidFill>
-          <a:ln w="12700">
+          <a:ln w="17780">
             <a:solidFill>
-              <a:srgbClr val="D9E2EC"/>
+              <a:srgbClr val="B0BEC5"/>
             </a:solidFill>
           </a:ln>
           <a:effectLst/>
@@ -8526,13 +8313,11 @@
             </a:avLst>
           </a:prstGeom>
           <a:solidFill>
-            <a:schemeClr val="bg1">
-              <a:lumMod val="85000"/>
-            </a:schemeClr>
+            <a:srgbClr val="E8EDF4"/>
           </a:solidFill>
-          <a:ln w="12700">
+          <a:ln w="17780">
             <a:solidFill>
-              <a:srgbClr val="D9E2EC"/>
+              <a:srgbClr val="B0BEC5"/>
             </a:solidFill>
           </a:ln>
           <a:effectLst/>
@@ -8987,7 +8772,7 @@
                 </a:solidFill>
                 <a:latin typeface="Arial"/>
               </a:rPr>
-              <a:t>18</a:t>
+              <a:t>17</a:t>
             </a:r>
           </a:p>
         </p:txBody>
@@ -10407,7 +10192,7 @@
                 </a:solidFill>
                 <a:latin typeface="Arial"/>
               </a:rPr>
-              <a:t>19</a:t>
+              <a:t>18</a:t>
             </a:r>
           </a:p>
         </p:txBody>
@@ -12142,7 +11927,7 @@
                 </a:solidFill>
                 <a:latin typeface="Arial"/>
               </a:rPr>
-              <a:t>20</a:t>
+              <a:t>19</a:t>
             </a:r>
           </a:p>
         </p:txBody>
@@ -13327,211 +13112,13 @@
               </a:defRPr>
             </a:pPr>
             <a:r>
-              <a:rPr sz="1300" b="0" dirty="0">
-                <a:solidFill>
-                  <a:srgbClr val="1F2937"/>
-                </a:solidFill>
-                <a:latin typeface="Arial"/>
-              </a:rPr>
-              <a:t>•  </a:t>
-            </a:r>
-            <a:r>
-              <a:rPr sz="1300" b="0" dirty="0" err="1">
-                <a:solidFill>
-                  <a:srgbClr val="1F2937"/>
-                </a:solidFill>
-                <a:latin typeface="Arial"/>
-              </a:rPr>
-              <a:t>Người</a:t>
-            </a:r>
-            <a:r>
-              <a:rPr sz="1300" b="0" dirty="0">
-                <a:solidFill>
-                  <a:srgbClr val="1F2937"/>
-                </a:solidFill>
-                <a:latin typeface="Arial"/>
-              </a:rPr>
-              <a:t> </a:t>
-            </a:r>
-            <a:r>
-              <a:rPr sz="1300" b="0" dirty="0" err="1">
-                <a:solidFill>
-                  <a:srgbClr val="1F2937"/>
-                </a:solidFill>
-                <a:latin typeface="Arial"/>
-              </a:rPr>
-              <a:t>dùng</a:t>
-            </a:r>
-            <a:r>
-              <a:rPr sz="1300" b="0" dirty="0">
-                <a:solidFill>
-                  <a:srgbClr val="1F2937"/>
-                </a:solidFill>
-                <a:latin typeface="Arial"/>
-              </a:rPr>
-              <a:t> </a:t>
-            </a:r>
-            <a:r>
-              <a:rPr sz="1300" b="0" dirty="0" err="1">
-                <a:solidFill>
-                  <a:srgbClr val="1F2937"/>
-                </a:solidFill>
-                <a:latin typeface="Arial"/>
-              </a:rPr>
-              <a:t>thường</a:t>
-            </a:r>
-            <a:r>
-              <a:rPr sz="1300" b="0" dirty="0">
-                <a:solidFill>
-                  <a:srgbClr val="1F2937"/>
-                </a:solidFill>
-                <a:latin typeface="Arial"/>
-              </a:rPr>
-              <a:t> </a:t>
-            </a:r>
-            <a:r>
-              <a:rPr sz="1300" b="0" dirty="0" err="1">
-                <a:solidFill>
-                  <a:srgbClr val="1F2937"/>
-                </a:solidFill>
-                <a:latin typeface="Arial"/>
-              </a:rPr>
-              <a:t>dò</a:t>
-            </a:r>
-            <a:r>
-              <a:rPr sz="1300" b="0" dirty="0">
-                <a:solidFill>
-                  <a:srgbClr val="1F2937"/>
-                </a:solidFill>
-                <a:latin typeface="Arial"/>
-              </a:rPr>
-              <a:t> </a:t>
-            </a:r>
-            <a:r>
-              <a:rPr sz="1300" b="0" dirty="0" err="1">
-                <a:solidFill>
-                  <a:srgbClr val="1F2937"/>
-                </a:solidFill>
-                <a:latin typeface="Arial"/>
-              </a:rPr>
-              <a:t>vé</a:t>
-            </a:r>
-            <a:r>
-              <a:rPr sz="1300" b="0" dirty="0">
-                <a:solidFill>
-                  <a:srgbClr val="1F2937"/>
-                </a:solidFill>
-                <a:latin typeface="Arial"/>
-              </a:rPr>
-              <a:t> </a:t>
-            </a:r>
-            <a:r>
-              <a:rPr sz="1300" b="0" dirty="0" err="1">
-                <a:solidFill>
-                  <a:srgbClr val="1F2937"/>
-                </a:solidFill>
-                <a:latin typeface="Arial"/>
-              </a:rPr>
-              <a:t>số</a:t>
-            </a:r>
-            <a:r>
-              <a:rPr sz="1300" b="0" dirty="0">
-                <a:solidFill>
-                  <a:srgbClr val="1F2937"/>
-                </a:solidFill>
-                <a:latin typeface="Arial"/>
-              </a:rPr>
-              <a:t> </a:t>
-            </a:r>
-            <a:r>
-              <a:rPr sz="1300" b="0" dirty="0" err="1">
-                <a:solidFill>
-                  <a:srgbClr val="1F2937"/>
-                </a:solidFill>
-                <a:latin typeface="Arial"/>
-              </a:rPr>
-              <a:t>thủ</a:t>
-            </a:r>
-            <a:r>
-              <a:rPr sz="1300" b="0" dirty="0">
-                <a:solidFill>
-                  <a:srgbClr val="1F2937"/>
-                </a:solidFill>
-                <a:latin typeface="Arial"/>
-              </a:rPr>
-              <a:t> </a:t>
-            </a:r>
-            <a:r>
-              <a:rPr sz="1300" b="0" dirty="0" err="1">
-                <a:solidFill>
-                  <a:srgbClr val="1F2937"/>
-                </a:solidFill>
-                <a:latin typeface="Arial"/>
-              </a:rPr>
-              <a:t>công</a:t>
-            </a:r>
-            <a:r>
-              <a:rPr sz="1300" b="0" dirty="0">
-                <a:solidFill>
-                  <a:srgbClr val="1F2937"/>
-                </a:solidFill>
-                <a:latin typeface="Arial"/>
-              </a:rPr>
-              <a:t>, </a:t>
-            </a:r>
-            <a:r>
-              <a:rPr sz="1300" b="0" dirty="0" err="1">
-                <a:solidFill>
-                  <a:srgbClr val="1F2937"/>
-                </a:solidFill>
-                <a:latin typeface="Arial"/>
-              </a:rPr>
-              <a:t>dễ</a:t>
-            </a:r>
-            <a:r>
-              <a:rPr sz="1300" b="0" dirty="0">
-                <a:solidFill>
-                  <a:srgbClr val="1F2937"/>
-                </a:solidFill>
-                <a:latin typeface="Arial"/>
-              </a:rPr>
-              <a:t> </a:t>
-            </a:r>
-            <a:r>
-              <a:rPr sz="1300" b="0" dirty="0" err="1">
-                <a:solidFill>
-                  <a:srgbClr val="1F2937"/>
-                </a:solidFill>
-                <a:latin typeface="Arial"/>
-              </a:rPr>
-              <a:t>sai</a:t>
-            </a:r>
-            <a:r>
-              <a:rPr sz="1300" b="0" dirty="0">
-                <a:solidFill>
-                  <a:srgbClr val="1F2937"/>
-                </a:solidFill>
-                <a:latin typeface="Arial"/>
-              </a:rPr>
-              <a:t> </a:t>
-            </a:r>
-            <a:r>
-              <a:rPr sz="1300" b="0" dirty="0" err="1">
-                <a:solidFill>
-                  <a:srgbClr val="1F2937"/>
-                </a:solidFill>
-                <a:latin typeface="Arial"/>
-              </a:rPr>
-              <a:t>sót</a:t>
-            </a:r>
-            <a:r>
-              <a:rPr sz="1300" b="0" dirty="0">
-                <a:solidFill>
-                  <a:srgbClr val="1F2937"/>
-                </a:solidFill>
-                <a:latin typeface="Arial"/>
-              </a:rPr>
-              <a:t>.</a:t>
+              <a:rPr sz="1300" b="0">
+                <a:solidFill>
+                  <a:srgbClr val="1F2937"/>
+                </a:solidFill>
+                <a:latin typeface="Arial"/>
+              </a:rPr>
+              <a:t>•  Người dùng thường dò vé số thủ công, dễ sai sót.</a:t>
             </a:r>
           </a:p>
           <a:p>
@@ -13550,121 +13137,13 @@
               </a:defRPr>
             </a:pPr>
             <a:r>
-              <a:rPr sz="1300" b="0" dirty="0">
-                <a:solidFill>
-                  <a:srgbClr val="1F2937"/>
-                </a:solidFill>
-                <a:latin typeface="Arial"/>
-              </a:rPr>
-              <a:t>•  </a:t>
-            </a:r>
-            <a:r>
-              <a:rPr sz="1300" b="0" dirty="0" err="1">
-                <a:solidFill>
-                  <a:srgbClr val="1F2937"/>
-                </a:solidFill>
-                <a:latin typeface="Arial"/>
-              </a:rPr>
-              <a:t>Khó</a:t>
-            </a:r>
-            <a:r>
-              <a:rPr sz="1300" b="0" dirty="0">
-                <a:solidFill>
-                  <a:srgbClr val="1F2937"/>
-                </a:solidFill>
-                <a:latin typeface="Arial"/>
-              </a:rPr>
-              <a:t> </a:t>
-            </a:r>
-            <a:r>
-              <a:rPr sz="1300" b="0" dirty="0" err="1">
-                <a:solidFill>
-                  <a:srgbClr val="1F2937"/>
-                </a:solidFill>
-                <a:latin typeface="Arial"/>
-              </a:rPr>
-              <a:t>dò</a:t>
-            </a:r>
-            <a:r>
-              <a:rPr sz="1300" b="0" dirty="0">
-                <a:solidFill>
-                  <a:srgbClr val="1F2937"/>
-                </a:solidFill>
-                <a:latin typeface="Arial"/>
-              </a:rPr>
-              <a:t> </a:t>
-            </a:r>
-            <a:r>
-              <a:rPr sz="1300" b="0" dirty="0" err="1">
-                <a:solidFill>
-                  <a:srgbClr val="1F2937"/>
-                </a:solidFill>
-                <a:latin typeface="Arial"/>
-              </a:rPr>
-              <a:t>nhiều</a:t>
-            </a:r>
-            <a:r>
-              <a:rPr sz="1300" b="0" dirty="0">
-                <a:solidFill>
-                  <a:srgbClr val="1F2937"/>
-                </a:solidFill>
-                <a:latin typeface="Arial"/>
-              </a:rPr>
-              <a:t> </a:t>
-            </a:r>
-            <a:r>
-              <a:rPr sz="1300" b="0" dirty="0" err="1">
-                <a:solidFill>
-                  <a:srgbClr val="1F2937"/>
-                </a:solidFill>
-                <a:latin typeface="Arial"/>
-              </a:rPr>
-              <a:t>vé</a:t>
-            </a:r>
-            <a:r>
-              <a:rPr sz="1300" b="0" dirty="0">
-                <a:solidFill>
-                  <a:srgbClr val="1F2937"/>
-                </a:solidFill>
-                <a:latin typeface="Arial"/>
-              </a:rPr>
-              <a:t> </a:t>
-            </a:r>
-            <a:r>
-              <a:rPr sz="1300" b="0" dirty="0" err="1">
-                <a:solidFill>
-                  <a:srgbClr val="1F2937"/>
-                </a:solidFill>
-                <a:latin typeface="Arial"/>
-              </a:rPr>
-              <a:t>cùng</a:t>
-            </a:r>
-            <a:r>
-              <a:rPr sz="1300" b="0" dirty="0">
-                <a:solidFill>
-                  <a:srgbClr val="1F2937"/>
-                </a:solidFill>
-                <a:latin typeface="Arial"/>
-              </a:rPr>
-              <a:t> </a:t>
-            </a:r>
-            <a:r>
-              <a:rPr sz="1300" b="0" dirty="0" err="1">
-                <a:solidFill>
-                  <a:srgbClr val="1F2937"/>
-                </a:solidFill>
-                <a:latin typeface="Arial"/>
-              </a:rPr>
-              <a:t>lúc</a:t>
-            </a:r>
-            <a:r>
-              <a:rPr sz="1300" b="0" dirty="0">
-                <a:solidFill>
-                  <a:srgbClr val="1F2937"/>
-                </a:solidFill>
-                <a:latin typeface="Arial"/>
-              </a:rPr>
-              <a:t>.</a:t>
+              <a:rPr sz="1300" b="0">
+                <a:solidFill>
+                  <a:srgbClr val="1F2937"/>
+                </a:solidFill>
+                <a:latin typeface="Arial"/>
+              </a:rPr>
+              <a:t>•  Khó dò nhiều vé cùng lúc.</a:t>
             </a:r>
           </a:p>
           <a:p>
@@ -13683,157 +13162,13 @@
               </a:defRPr>
             </a:pPr>
             <a:r>
-              <a:rPr sz="1300" b="0" dirty="0">
-                <a:solidFill>
-                  <a:srgbClr val="1F2937"/>
-                </a:solidFill>
-                <a:latin typeface="Arial"/>
-              </a:rPr>
-              <a:t>•  </a:t>
-            </a:r>
-            <a:r>
-              <a:rPr sz="1300" b="0" dirty="0" err="1">
-                <a:solidFill>
-                  <a:srgbClr val="1F2937"/>
-                </a:solidFill>
-                <a:latin typeface="Arial"/>
-              </a:rPr>
-              <a:t>Khó</a:t>
-            </a:r>
-            <a:r>
-              <a:rPr sz="1300" b="0" dirty="0">
-                <a:solidFill>
-                  <a:srgbClr val="1F2937"/>
-                </a:solidFill>
-                <a:latin typeface="Arial"/>
-              </a:rPr>
-              <a:t> </a:t>
-            </a:r>
-            <a:r>
-              <a:rPr sz="1300" b="0" dirty="0" err="1">
-                <a:solidFill>
-                  <a:srgbClr val="1F2937"/>
-                </a:solidFill>
-                <a:latin typeface="Arial"/>
-              </a:rPr>
-              <a:t>lưu</a:t>
-            </a:r>
-            <a:r>
-              <a:rPr sz="1300" b="0" dirty="0">
-                <a:solidFill>
-                  <a:srgbClr val="1F2937"/>
-                </a:solidFill>
-                <a:latin typeface="Arial"/>
-              </a:rPr>
-              <a:t> </a:t>
-            </a:r>
-            <a:r>
-              <a:rPr sz="1300" b="0" dirty="0" err="1">
-                <a:solidFill>
-                  <a:srgbClr val="1F2937"/>
-                </a:solidFill>
-                <a:latin typeface="Arial"/>
-              </a:rPr>
-              <a:t>lại</a:t>
-            </a:r>
-            <a:r>
-              <a:rPr sz="1300" b="0" dirty="0">
-                <a:solidFill>
-                  <a:srgbClr val="1F2937"/>
-                </a:solidFill>
-                <a:latin typeface="Arial"/>
-              </a:rPr>
-              <a:t> </a:t>
-            </a:r>
-            <a:r>
-              <a:rPr sz="1300" b="0" dirty="0" err="1">
-                <a:solidFill>
-                  <a:srgbClr val="1F2937"/>
-                </a:solidFill>
-                <a:latin typeface="Arial"/>
-              </a:rPr>
-              <a:t>lịch</a:t>
-            </a:r>
-            <a:r>
-              <a:rPr sz="1300" b="0" dirty="0">
-                <a:solidFill>
-                  <a:srgbClr val="1F2937"/>
-                </a:solidFill>
-                <a:latin typeface="Arial"/>
-              </a:rPr>
-              <a:t> </a:t>
-            </a:r>
-            <a:r>
-              <a:rPr sz="1300" b="0" dirty="0" err="1">
-                <a:solidFill>
-                  <a:srgbClr val="1F2937"/>
-                </a:solidFill>
-                <a:latin typeface="Arial"/>
-              </a:rPr>
-              <a:t>sử</a:t>
-            </a:r>
-            <a:r>
-              <a:rPr sz="1300" b="0" dirty="0">
-                <a:solidFill>
-                  <a:srgbClr val="1F2937"/>
-                </a:solidFill>
-                <a:latin typeface="Arial"/>
-              </a:rPr>
-              <a:t> </a:t>
-            </a:r>
-            <a:r>
-              <a:rPr sz="1300" b="0" dirty="0" err="1">
-                <a:solidFill>
-                  <a:srgbClr val="1F2937"/>
-                </a:solidFill>
-                <a:latin typeface="Arial"/>
-              </a:rPr>
-              <a:t>các</a:t>
-            </a:r>
-            <a:r>
-              <a:rPr sz="1300" b="0" dirty="0">
-                <a:solidFill>
-                  <a:srgbClr val="1F2937"/>
-                </a:solidFill>
-                <a:latin typeface="Arial"/>
-              </a:rPr>
-              <a:t> </a:t>
-            </a:r>
-            <a:r>
-              <a:rPr sz="1300" b="0" dirty="0" err="1">
-                <a:solidFill>
-                  <a:srgbClr val="1F2937"/>
-                </a:solidFill>
-                <a:latin typeface="Arial"/>
-              </a:rPr>
-              <a:t>lần</a:t>
-            </a:r>
-            <a:r>
-              <a:rPr sz="1300" b="0" dirty="0">
-                <a:solidFill>
-                  <a:srgbClr val="1F2937"/>
-                </a:solidFill>
-                <a:latin typeface="Arial"/>
-              </a:rPr>
-              <a:t> </a:t>
-            </a:r>
-            <a:r>
-              <a:rPr sz="1300" b="0" dirty="0" err="1">
-                <a:solidFill>
-                  <a:srgbClr val="1F2937"/>
-                </a:solidFill>
-                <a:latin typeface="Arial"/>
-              </a:rPr>
-              <a:t>dò</a:t>
-            </a:r>
-            <a:r>
-              <a:rPr sz="1300" b="0" dirty="0">
-                <a:solidFill>
-                  <a:srgbClr val="1F2937"/>
-                </a:solidFill>
-                <a:latin typeface="Arial"/>
-              </a:rPr>
-              <a:t>.</a:t>
+              <a:rPr sz="1300" b="0">
+                <a:solidFill>
+                  <a:srgbClr val="1F2937"/>
+                </a:solidFill>
+                <a:latin typeface="Arial"/>
+              </a:rPr>
+              <a:t>•  Khó lưu lại lịch sử các lần dò.</a:t>
             </a:r>
           </a:p>
           <a:p>
@@ -13852,211 +13187,13 @@
               </a:defRPr>
             </a:pPr>
             <a:r>
-              <a:rPr sz="1300" b="0" dirty="0">
-                <a:solidFill>
-                  <a:srgbClr val="1F2937"/>
-                </a:solidFill>
-                <a:latin typeface="Arial"/>
-              </a:rPr>
-              <a:t>•  Admin </a:t>
-            </a:r>
-            <a:r>
-              <a:rPr sz="1300" b="0" dirty="0" err="1">
-                <a:solidFill>
-                  <a:srgbClr val="1F2937"/>
-                </a:solidFill>
-                <a:latin typeface="Arial"/>
-              </a:rPr>
-              <a:t>cần</a:t>
-            </a:r>
-            <a:r>
-              <a:rPr sz="1300" b="0" dirty="0">
-                <a:solidFill>
-                  <a:srgbClr val="1F2937"/>
-                </a:solidFill>
-                <a:latin typeface="Arial"/>
-              </a:rPr>
-              <a:t> </a:t>
-            </a:r>
-            <a:r>
-              <a:rPr sz="1300" b="0" dirty="0" err="1">
-                <a:solidFill>
-                  <a:srgbClr val="1F2937"/>
-                </a:solidFill>
-                <a:latin typeface="Arial"/>
-              </a:rPr>
-              <a:t>quản</a:t>
-            </a:r>
-            <a:r>
-              <a:rPr sz="1300" b="0" dirty="0">
-                <a:solidFill>
-                  <a:srgbClr val="1F2937"/>
-                </a:solidFill>
-                <a:latin typeface="Arial"/>
-              </a:rPr>
-              <a:t> </a:t>
-            </a:r>
-            <a:r>
-              <a:rPr sz="1300" b="0" dirty="0" err="1">
-                <a:solidFill>
-                  <a:srgbClr val="1F2937"/>
-                </a:solidFill>
-                <a:latin typeface="Arial"/>
-              </a:rPr>
-              <a:t>lý</a:t>
-            </a:r>
-            <a:r>
-              <a:rPr sz="1300" b="0" dirty="0">
-                <a:solidFill>
-                  <a:srgbClr val="1F2937"/>
-                </a:solidFill>
-                <a:latin typeface="Arial"/>
-              </a:rPr>
-              <a:t> </a:t>
-            </a:r>
-            <a:r>
-              <a:rPr sz="1300" b="0" dirty="0" err="1">
-                <a:solidFill>
-                  <a:srgbClr val="1F2937"/>
-                </a:solidFill>
-                <a:latin typeface="Arial"/>
-              </a:rPr>
-              <a:t>kết</a:t>
-            </a:r>
-            <a:r>
-              <a:rPr sz="1300" b="0" dirty="0">
-                <a:solidFill>
-                  <a:srgbClr val="1F2937"/>
-                </a:solidFill>
-                <a:latin typeface="Arial"/>
-              </a:rPr>
-              <a:t> </a:t>
-            </a:r>
-            <a:r>
-              <a:rPr sz="1300" b="0" dirty="0" err="1">
-                <a:solidFill>
-                  <a:srgbClr val="1F2937"/>
-                </a:solidFill>
-                <a:latin typeface="Arial"/>
-              </a:rPr>
-              <a:t>quả</a:t>
-            </a:r>
-            <a:r>
-              <a:rPr sz="1300" b="0" dirty="0">
-                <a:solidFill>
-                  <a:srgbClr val="1F2937"/>
-                </a:solidFill>
-                <a:latin typeface="Arial"/>
-              </a:rPr>
-              <a:t> </a:t>
-            </a:r>
-            <a:r>
-              <a:rPr sz="1300" b="0" dirty="0" err="1">
-                <a:solidFill>
-                  <a:srgbClr val="1F2937"/>
-                </a:solidFill>
-                <a:latin typeface="Arial"/>
-              </a:rPr>
-              <a:t>xổ</a:t>
-            </a:r>
-            <a:r>
-              <a:rPr sz="1300" b="0" dirty="0">
-                <a:solidFill>
-                  <a:srgbClr val="1F2937"/>
-                </a:solidFill>
-                <a:latin typeface="Arial"/>
-              </a:rPr>
-              <a:t> </a:t>
-            </a:r>
-            <a:r>
-              <a:rPr sz="1300" b="0" dirty="0" err="1">
-                <a:solidFill>
-                  <a:srgbClr val="1F2937"/>
-                </a:solidFill>
-                <a:latin typeface="Arial"/>
-              </a:rPr>
-              <a:t>số</a:t>
-            </a:r>
-            <a:r>
-              <a:rPr sz="1300" b="0" dirty="0">
-                <a:solidFill>
-                  <a:srgbClr val="1F2937"/>
-                </a:solidFill>
-                <a:latin typeface="Arial"/>
-              </a:rPr>
-              <a:t> </a:t>
-            </a:r>
-            <a:r>
-              <a:rPr sz="1300" b="0" dirty="0" err="1">
-                <a:solidFill>
-                  <a:srgbClr val="1F2937"/>
-                </a:solidFill>
-                <a:latin typeface="Arial"/>
-              </a:rPr>
-              <a:t>theo</a:t>
-            </a:r>
-            <a:r>
-              <a:rPr sz="1300" b="0" dirty="0">
-                <a:solidFill>
-                  <a:srgbClr val="1F2937"/>
-                </a:solidFill>
-                <a:latin typeface="Arial"/>
-              </a:rPr>
-              <a:t> </a:t>
-            </a:r>
-            <a:r>
-              <a:rPr sz="1300" b="0" dirty="0" err="1">
-                <a:solidFill>
-                  <a:srgbClr val="1F2937"/>
-                </a:solidFill>
-                <a:latin typeface="Arial"/>
-              </a:rPr>
-              <a:t>đài</a:t>
-            </a:r>
-            <a:r>
-              <a:rPr sz="1300" b="0" dirty="0">
-                <a:solidFill>
-                  <a:srgbClr val="1F2937"/>
-                </a:solidFill>
-                <a:latin typeface="Arial"/>
-              </a:rPr>
-              <a:t> </a:t>
-            </a:r>
-            <a:r>
-              <a:rPr sz="1300" b="0" dirty="0" err="1">
-                <a:solidFill>
-                  <a:srgbClr val="1F2937"/>
-                </a:solidFill>
-                <a:latin typeface="Arial"/>
-              </a:rPr>
-              <a:t>và</a:t>
-            </a:r>
-            <a:r>
-              <a:rPr sz="1300" b="0" dirty="0">
-                <a:solidFill>
-                  <a:srgbClr val="1F2937"/>
-                </a:solidFill>
-                <a:latin typeface="Arial"/>
-              </a:rPr>
-              <a:t> </a:t>
-            </a:r>
-            <a:r>
-              <a:rPr sz="1300" b="0" dirty="0" err="1">
-                <a:solidFill>
-                  <a:srgbClr val="1F2937"/>
-                </a:solidFill>
-                <a:latin typeface="Arial"/>
-              </a:rPr>
-              <a:t>ngày</a:t>
-            </a:r>
-            <a:r>
-              <a:rPr sz="1300" b="0" dirty="0">
-                <a:solidFill>
-                  <a:srgbClr val="1F2937"/>
-                </a:solidFill>
-                <a:latin typeface="Arial"/>
-              </a:rPr>
-              <a:t>.</a:t>
+              <a:rPr sz="1300" b="0">
+                <a:solidFill>
+                  <a:srgbClr val="1F2937"/>
+                </a:solidFill>
+                <a:latin typeface="Arial"/>
+              </a:rPr>
+              <a:t>•  Admin cần quản lý kết quả xổ số theo đài và ngày.</a:t>
             </a:r>
           </a:p>
           <a:p>
@@ -14075,229 +13212,13 @@
               </a:defRPr>
             </a:pPr>
             <a:r>
-              <a:rPr sz="1300" b="0" dirty="0">
-                <a:solidFill>
-                  <a:srgbClr val="1F2937"/>
-                </a:solidFill>
-                <a:latin typeface="Arial"/>
-              </a:rPr>
-              <a:t>•  </a:t>
-            </a:r>
-            <a:r>
-              <a:rPr sz="1300" b="0" dirty="0" err="1">
-                <a:solidFill>
-                  <a:srgbClr val="1F2937"/>
-                </a:solidFill>
-                <a:latin typeface="Arial"/>
-              </a:rPr>
-              <a:t>Cần</a:t>
-            </a:r>
-            <a:r>
-              <a:rPr sz="1300" b="0" dirty="0">
-                <a:solidFill>
-                  <a:srgbClr val="1F2937"/>
-                </a:solidFill>
-                <a:latin typeface="Arial"/>
-              </a:rPr>
-              <a:t> </a:t>
-            </a:r>
-            <a:r>
-              <a:rPr sz="1300" b="0" dirty="0" err="1">
-                <a:solidFill>
-                  <a:srgbClr val="1F2937"/>
-                </a:solidFill>
-                <a:latin typeface="Arial"/>
-              </a:rPr>
-              <a:t>phân</a:t>
-            </a:r>
-            <a:r>
-              <a:rPr sz="1300" b="0" dirty="0">
-                <a:solidFill>
-                  <a:srgbClr val="1F2937"/>
-                </a:solidFill>
-                <a:latin typeface="Arial"/>
-              </a:rPr>
-              <a:t> </a:t>
-            </a:r>
-            <a:r>
-              <a:rPr sz="1300" b="0" dirty="0" err="1">
-                <a:solidFill>
-                  <a:srgbClr val="1F2937"/>
-                </a:solidFill>
-                <a:latin typeface="Arial"/>
-              </a:rPr>
-              <a:t>quyền</a:t>
-            </a:r>
-            <a:r>
-              <a:rPr sz="1300" b="0" dirty="0">
-                <a:solidFill>
-                  <a:srgbClr val="1F2937"/>
-                </a:solidFill>
-                <a:latin typeface="Arial"/>
-              </a:rPr>
-              <a:t> </a:t>
-            </a:r>
-            <a:r>
-              <a:rPr sz="1300" b="0" dirty="0" err="1">
-                <a:solidFill>
-                  <a:srgbClr val="1F2937"/>
-                </a:solidFill>
-                <a:latin typeface="Arial"/>
-              </a:rPr>
-              <a:t>người</a:t>
-            </a:r>
-            <a:r>
-              <a:rPr sz="1300" b="0" dirty="0">
-                <a:solidFill>
-                  <a:srgbClr val="1F2937"/>
-                </a:solidFill>
-                <a:latin typeface="Arial"/>
-              </a:rPr>
-              <a:t> </a:t>
-            </a:r>
-            <a:r>
-              <a:rPr sz="1300" b="0" dirty="0" err="1">
-                <a:solidFill>
-                  <a:srgbClr val="1F2937"/>
-                </a:solidFill>
-                <a:latin typeface="Arial"/>
-              </a:rPr>
-              <a:t>dùng</a:t>
-            </a:r>
-            <a:r>
-              <a:rPr sz="1300" b="0" dirty="0">
-                <a:solidFill>
-                  <a:srgbClr val="1F2937"/>
-                </a:solidFill>
-                <a:latin typeface="Arial"/>
-              </a:rPr>
-              <a:t> </a:t>
-            </a:r>
-            <a:r>
-              <a:rPr sz="1300" b="0" dirty="0" err="1">
-                <a:solidFill>
-                  <a:srgbClr val="1F2937"/>
-                </a:solidFill>
-                <a:latin typeface="Arial"/>
-              </a:rPr>
-              <a:t>và</a:t>
-            </a:r>
-            <a:r>
-              <a:rPr sz="1300" b="0" dirty="0">
-                <a:solidFill>
-                  <a:srgbClr val="1F2937"/>
-                </a:solidFill>
-                <a:latin typeface="Arial"/>
-              </a:rPr>
-              <a:t> </a:t>
-            </a:r>
-            <a:r>
-              <a:rPr sz="1300" b="0" dirty="0" err="1">
-                <a:solidFill>
-                  <a:srgbClr val="1F2937"/>
-                </a:solidFill>
-                <a:latin typeface="Arial"/>
-              </a:rPr>
-              <a:t>kiểm</a:t>
-            </a:r>
-            <a:r>
-              <a:rPr sz="1300" b="0" dirty="0">
-                <a:solidFill>
-                  <a:srgbClr val="1F2937"/>
-                </a:solidFill>
-                <a:latin typeface="Arial"/>
-              </a:rPr>
-              <a:t> </a:t>
-            </a:r>
-            <a:r>
-              <a:rPr sz="1300" b="0" dirty="0" err="1">
-                <a:solidFill>
-                  <a:srgbClr val="1F2937"/>
-                </a:solidFill>
-                <a:latin typeface="Arial"/>
-              </a:rPr>
-              <a:t>soát</a:t>
-            </a:r>
-            <a:r>
-              <a:rPr sz="1300" b="0" dirty="0">
-                <a:solidFill>
-                  <a:srgbClr val="1F2937"/>
-                </a:solidFill>
-                <a:latin typeface="Arial"/>
-              </a:rPr>
-              <a:t> </a:t>
-            </a:r>
-            <a:r>
-              <a:rPr sz="1300" b="0" dirty="0" err="1">
-                <a:solidFill>
-                  <a:srgbClr val="1F2937"/>
-                </a:solidFill>
-                <a:latin typeface="Arial"/>
-              </a:rPr>
-              <a:t>dữ</a:t>
-            </a:r>
-            <a:r>
-              <a:rPr sz="1300" b="0" dirty="0">
-                <a:solidFill>
-                  <a:srgbClr val="1F2937"/>
-                </a:solidFill>
-                <a:latin typeface="Arial"/>
-              </a:rPr>
-              <a:t> </a:t>
-            </a:r>
-            <a:r>
-              <a:rPr sz="1300" b="0" dirty="0" err="1">
-                <a:solidFill>
-                  <a:srgbClr val="1F2937"/>
-                </a:solidFill>
-                <a:latin typeface="Arial"/>
-              </a:rPr>
-              <a:t>liệu</a:t>
-            </a:r>
-            <a:r>
-              <a:rPr sz="1300" b="0" dirty="0">
-                <a:solidFill>
-                  <a:srgbClr val="1F2937"/>
-                </a:solidFill>
-                <a:latin typeface="Arial"/>
-              </a:rPr>
-              <a:t> </a:t>
-            </a:r>
-            <a:r>
-              <a:rPr sz="1300" b="0" dirty="0" err="1">
-                <a:solidFill>
-                  <a:srgbClr val="1F2937"/>
-                </a:solidFill>
-                <a:latin typeface="Arial"/>
-              </a:rPr>
-              <a:t>công</a:t>
-            </a:r>
-            <a:r>
-              <a:rPr sz="1300" b="0" dirty="0">
-                <a:solidFill>
-                  <a:srgbClr val="1F2937"/>
-                </a:solidFill>
-                <a:latin typeface="Arial"/>
-              </a:rPr>
-              <a:t> </a:t>
-            </a:r>
-            <a:r>
-              <a:rPr sz="1300" b="0" dirty="0" err="1">
-                <a:solidFill>
-                  <a:srgbClr val="1F2937"/>
-                </a:solidFill>
-                <a:latin typeface="Arial"/>
-              </a:rPr>
-              <a:t>bố</a:t>
-            </a:r>
-            <a:r>
-              <a:rPr sz="1300" b="0" dirty="0">
-                <a:solidFill>
-                  <a:srgbClr val="1F2937"/>
-                </a:solidFill>
-                <a:latin typeface="Arial"/>
-              </a:rPr>
-              <a:t>.</a:t>
+              <a:rPr sz="1300" b="0">
+                <a:solidFill>
+                  <a:srgbClr val="1F2937"/>
+                </a:solidFill>
+                <a:latin typeface="Arial"/>
+              </a:rPr>
+              <a:t>•  Cần phân quyền người dùng và kiểm soát dữ liệu công bố.</a:t>
             </a:r>
           </a:p>
         </p:txBody>
@@ -14512,7 +13433,7 @@
                 </a:solidFill>
                 <a:latin typeface="Arial"/>
               </a:rPr>
-              <a:t>•  Hỗ trợ guest, user và admin.</a:t>
+              <a:t>•  Hỗ trợ 3 nhóm người dùng: Guest (chưa đăng nhập), User (đã đăng nhập), Admin.</a:t>
             </a:r>
           </a:p>
           <a:p>
@@ -14600,8 +13521,8 @@
         </p:nvSpPr>
         <p:spPr>
           <a:xfrm>
-            <a:off x="777240" y="5166359"/>
-            <a:ext cx="10634472" cy="1200573"/>
+            <a:off x="777240" y="5166360"/>
+            <a:ext cx="10634472" cy="1173480"/>
           </a:xfrm>
           <a:prstGeom prst="roundRect">
             <a:avLst>
@@ -14650,7 +13571,7 @@
         <p:spPr>
           <a:xfrm>
             <a:off x="777240" y="5330952"/>
-            <a:ext cx="82296" cy="850392"/>
+            <a:ext cx="82296" cy="630936"/>
           </a:xfrm>
           <a:prstGeom prst="rect">
             <a:avLst/>
@@ -14742,7 +13663,7 @@
         </p:nvSpPr>
         <p:spPr>
           <a:xfrm>
-            <a:off x="982980" y="5595112"/>
+            <a:off x="963168" y="5596128"/>
             <a:ext cx="10222992" cy="210312"/>
           </a:xfrm>
           <a:prstGeom prst="rect">
@@ -15637,7 +14558,7 @@
                 </a:solidFill>
                 <a:latin typeface="Arial"/>
               </a:rPr>
-              <a:t>21</a:t>
+              <a:t>20</a:t>
             </a:r>
           </a:p>
         </p:txBody>
@@ -15827,7 +14748,7 @@
                 </a:solidFill>
                 <a:latin typeface="Arial"/>
               </a:rPr>
-              <a:t>•  Một số chức năng optional chưa hoàn thành: AdSense, gamification comment, preview vé dò.</a:t>
+              <a:t>•  Chưa hoàn thành: Google AdSense (FR 1.7), gamification comments (FR 2.6), preview vé dò (FR 3.15).</a:t>
             </a:r>
           </a:p>
           <a:p>
@@ -16627,7 +15548,7 @@
                 </a:solidFill>
                 <a:latin typeface="Arial"/>
               </a:rPr>
-              <a:t>22</a:t>
+              <a:t>21</a:t>
             </a:r>
           </a:p>
         </p:txBody>
@@ -24420,7 +23341,7 @@
         </p:nvSpPr>
         <p:spPr>
           <a:xfrm>
-            <a:off x="1005840" y="5257800"/>
+            <a:off x="1014984" y="5239512"/>
             <a:ext cx="10222992" cy="621792"/>
           </a:xfrm>
           <a:prstGeom prst="rect">
@@ -25715,11 +24636,11 @@
             </a:avLst>
           </a:prstGeom>
           <a:solidFill>
-            <a:srgbClr val="FFFFFF"/>
+            <a:srgbClr val="E8EDF4"/>
           </a:solidFill>
-          <a:ln w="12700">
+          <a:ln w="17780">
             <a:solidFill>
-              <a:srgbClr val="D9E2EC"/>
+              <a:srgbClr val="B0BEC5"/>
             </a:solidFill>
           </a:ln>
           <a:effectLst/>
@@ -25747,63 +24668,9 @@
           </a:p>
         </p:txBody>
       </p:sp>
-      <p:sp>
-        <p:nvSpPr>
-          <p:cNvPr id="11" name="TextBox 10"/>
-          <p:cNvSpPr txBox="1"/>
-          <p:nvPr/>
-        </p:nvSpPr>
-        <p:spPr>
-          <a:xfrm>
-            <a:off x="777240" y="5852160"/>
-            <a:ext cx="10634472" cy="274320"/>
-          </a:xfrm>
-          <a:prstGeom prst="rect">
-            <a:avLst/>
-          </a:prstGeom>
-          <a:noFill/>
-        </p:spPr>
-        <p:txBody>
-          <a:bodyPr wrap="square" lIns="0" tIns="0" rIns="0" bIns="0" anchor="t">
-            <a:spAutoFit/>
-          </a:bodyPr>
-          <a:lstStyle/>
-          <a:p>
-            <a:pPr algn="ctr">
-              <a:lnSpc>
-                <a:spcPct val="105000"/>
-              </a:lnSpc>
-              <a:spcAft>
-                <a:spcPts val="0"/>
-              </a:spcAft>
-              <a:defRPr sz="1000" b="0">
-                <a:solidFill>
-                  <a:srgbClr val="6B7280"/>
-                </a:solidFill>
-                <a:latin typeface="Arial"/>
-              </a:defRPr>
-            </a:pPr>
-            <a:r>
-              <a:rPr sz="1000" b="0">
-                <a:solidFill>
-                  <a:srgbClr val="6B7280"/>
-                </a:solidFill>
-                <a:latin typeface="Arial"/>
-              </a:rPr>
-              <a:t>Sơ đồ use case: Guest, User, Admin với các nhóm chức năng chính</a:t>
-            </a:r>
-          </a:p>
-        </p:txBody>
-      </p:sp>
       <p:pic>
         <p:nvPicPr>
-          <p:cNvPr id="13" name="Picture 12">
-            <a:extLst>
-              <a:ext uri="{FF2B5EF4-FFF2-40B4-BE49-F238E27FC236}">
-                <a16:creationId xmlns:a16="http://schemas.microsoft.com/office/drawing/2014/main" id="{96D846F2-0574-73E7-E1C1-E4B92BE9506B}"/>
-              </a:ext>
-            </a:extLst>
-          </p:cNvPr>
+          <p:cNvPr id="10" name="Picture 9" descr="usecase-diagram.png"/>
           <p:cNvPicPr>
             <a:picLocks noChangeAspect="1"/>
           </p:cNvPicPr>
@@ -25817,14 +24684,62 @@
         </p:blipFill>
         <p:spPr>
           <a:xfrm>
-            <a:off x="934719" y="1990344"/>
-            <a:ext cx="10358121" cy="3481158"/>
+            <a:off x="777240" y="2162240"/>
+            <a:ext cx="10634472" cy="3036439"/>
           </a:xfrm>
           <a:prstGeom prst="rect">
             <a:avLst/>
           </a:prstGeom>
         </p:spPr>
       </p:pic>
+      <p:sp>
+        <p:nvSpPr>
+          <p:cNvPr id="11" name="TextBox 10"/>
+          <p:cNvSpPr txBox="1"/>
+          <p:nvPr/>
+        </p:nvSpPr>
+        <p:spPr>
+          <a:xfrm>
+            <a:off x="777240" y="5852160"/>
+            <a:ext cx="10634472" cy="274320"/>
+          </a:xfrm>
+          <a:prstGeom prst="rect">
+            <a:avLst/>
+          </a:prstGeom>
+          <a:noFill/>
+        </p:spPr>
+        <p:txBody>
+          <a:bodyPr wrap="square" lIns="0" tIns="0" rIns="0" bIns="0" anchor="t">
+            <a:spAutoFit/>
+          </a:bodyPr>
+          <a:lstStyle/>
+          <a:p>
+            <a:pPr algn="ctr">
+              <a:lnSpc>
+                <a:spcPct val="105000"/>
+              </a:lnSpc>
+              <a:spcAft>
+                <a:spcPts val="0"/>
+              </a:spcAft>
+              <a:defRPr sz="1000" b="0">
+                <a:solidFill>
+                  <a:srgbClr val="6B7280"/>
+                </a:solidFill>
+                <a:latin typeface="Arial"/>
+              </a:defRPr>
+            </a:pPr>
+            <a:r>
+              <a:rPr sz="1000" b="0">
+                <a:solidFill>
+                  <a:srgbClr val="6B7280"/>
+                </a:solidFill>
+                <a:latin typeface="Arial"/>
+              </a:rPr>
+              <a:t>Sơ đồ use case: Guest, User, Admin với các nhóm chức năng chính</a:t>
+            </a:r>
+          </a:p>
+        </p:txBody>
+      </p:sp>
     </p:spTree>
   </p:cSld>
   <p:clrMapOvr>
@@ -27189,7 +26104,7 @@
         <p:spPr>
           <a:xfrm>
             <a:off x="777240" y="4754880"/>
-            <a:ext cx="10634472" cy="1586714"/>
+            <a:ext cx="10634472" cy="1664208"/>
           </a:xfrm>
           <a:prstGeom prst="roundRect">
             <a:avLst>
@@ -27238,7 +26153,7 @@
         <p:spPr>
           <a:xfrm>
             <a:off x="777240" y="4919472"/>
-            <a:ext cx="82296" cy="1198456"/>
+            <a:ext cx="82296" cy="1042416"/>
           </a:xfrm>
           <a:prstGeom prst="rect">
             <a:avLst/>
@@ -27330,7 +26245,7 @@
         </p:nvSpPr>
         <p:spPr>
           <a:xfrm>
-            <a:off x="1014984" y="5201357"/>
+            <a:off x="987552" y="5106924"/>
             <a:ext cx="10222992" cy="621792"/>
           </a:xfrm>
           <a:prstGeom prst="rect">
@@ -27733,6 +26648,139 @@
                 <a:latin typeface="Arial"/>
               </a:rPr>
               <a:t>.</a:t>
+            </a:r>
+          </a:p>
+          <a:p>
+            <a:pPr algn="l">
+              <a:lnSpc>
+                <a:spcPct val="108000"/>
+              </a:lnSpc>
+              <a:spcAft>
+                <a:spcPts val="500"/>
+              </a:spcAft>
+              <a:defRPr sz="1300" b="0">
+                <a:solidFill>
+                  <a:srgbClr val="1F2937"/>
+                </a:solidFill>
+                <a:latin typeface="Arial"/>
+              </a:defRPr>
+            </a:pPr>
+            <a:r>
+              <a:rPr sz="1300" b="0" dirty="0">
+                <a:solidFill>
+                  <a:srgbClr val="1F2937"/>
+                </a:solidFill>
+                <a:latin typeface="Arial"/>
+              </a:rPr>
+              <a:t>•  React </a:t>
+            </a:r>
+            <a:r>
+              <a:rPr sz="1300" b="0" dirty="0" err="1">
+                <a:solidFill>
+                  <a:srgbClr val="1F2937"/>
+                </a:solidFill>
+                <a:latin typeface="Arial"/>
+              </a:rPr>
+              <a:t>và</a:t>
+            </a:r>
+            <a:r>
+              <a:rPr sz="1300" b="0" dirty="0">
+                <a:solidFill>
+                  <a:srgbClr val="1F2937"/>
+                </a:solidFill>
+                <a:latin typeface="Arial"/>
+              </a:rPr>
+              <a:t> Ant Design </a:t>
+            </a:r>
+            <a:r>
+              <a:rPr sz="1300" b="0" dirty="0" err="1">
+                <a:solidFill>
+                  <a:srgbClr val="1F2937"/>
+                </a:solidFill>
+                <a:latin typeface="Arial"/>
+              </a:rPr>
+              <a:t>được</a:t>
+            </a:r>
+            <a:r>
+              <a:rPr sz="1300" b="0" dirty="0">
+                <a:solidFill>
+                  <a:srgbClr val="1F2937"/>
+                </a:solidFill>
+                <a:latin typeface="Arial"/>
+              </a:rPr>
+              <a:t> mentor </a:t>
+            </a:r>
+            <a:r>
+              <a:rPr sz="1300" b="0" dirty="0" err="1">
+                <a:solidFill>
+                  <a:srgbClr val="1F2937"/>
+                </a:solidFill>
+                <a:latin typeface="Arial"/>
+              </a:rPr>
+              <a:t>chấp</a:t>
+            </a:r>
+            <a:r>
+              <a:rPr sz="1300" b="0" dirty="0">
+                <a:solidFill>
+                  <a:srgbClr val="1F2937"/>
+                </a:solidFill>
+                <a:latin typeface="Arial"/>
+              </a:rPr>
+              <a:t> </a:t>
+            </a:r>
+            <a:r>
+              <a:rPr sz="1300" b="0" dirty="0" err="1">
+                <a:solidFill>
+                  <a:srgbClr val="1F2937"/>
+                </a:solidFill>
+                <a:latin typeface="Arial"/>
+              </a:rPr>
+              <a:t>thuận</a:t>
+            </a:r>
+            <a:r>
+              <a:rPr sz="1300" b="0" dirty="0">
+                <a:solidFill>
+                  <a:srgbClr val="1F2937"/>
+                </a:solidFill>
+                <a:latin typeface="Arial"/>
+              </a:rPr>
+              <a:t> </a:t>
+            </a:r>
+            <a:r>
+              <a:rPr sz="1300" b="0" dirty="0" err="1">
+                <a:solidFill>
+                  <a:srgbClr val="1F2937"/>
+                </a:solidFill>
+                <a:latin typeface="Arial"/>
+              </a:rPr>
+              <a:t>thay</a:t>
+            </a:r>
+            <a:r>
+              <a:rPr sz="1300" b="0" dirty="0">
+                <a:solidFill>
+                  <a:srgbClr val="1F2937"/>
+                </a:solidFill>
+                <a:latin typeface="Arial"/>
+              </a:rPr>
+              <a:t> </a:t>
+            </a:r>
+            <a:r>
+              <a:rPr sz="1300" b="0" dirty="0" err="1">
+                <a:solidFill>
+                  <a:srgbClr val="1F2937"/>
+                </a:solidFill>
+                <a:latin typeface="Arial"/>
+              </a:rPr>
+              <a:t>thế</a:t>
+            </a:r>
+            <a:r>
+              <a:rPr sz="1300" b="0" dirty="0">
+                <a:solidFill>
+                  <a:srgbClr val="1F2937"/>
+                </a:solidFill>
+                <a:latin typeface="Arial"/>
+              </a:rPr>
+              <a:t> Bootstrap.</a:t>
             </a:r>
           </a:p>
           <a:p>
@@ -28506,11 +27554,11 @@
             </a:avLst>
           </a:prstGeom>
           <a:solidFill>
-            <a:srgbClr val="FFFFFF"/>
+            <a:srgbClr val="E8EDF4"/>
           </a:solidFill>
-          <a:ln w="12700">
+          <a:ln w="17780">
             <a:solidFill>
-              <a:srgbClr val="D9E2EC"/>
+              <a:srgbClr val="B0BEC5"/>
             </a:solidFill>
           </a:ln>
           <a:effectLst/>
@@ -28538,63 +27586,9 @@
           </a:p>
         </p:txBody>
       </p:sp>
-      <p:sp>
-        <p:nvSpPr>
-          <p:cNvPr id="11" name="TextBox 10"/>
-          <p:cNvSpPr txBox="1"/>
-          <p:nvPr/>
-        </p:nvSpPr>
-        <p:spPr>
-          <a:xfrm>
-            <a:off x="777240" y="5852160"/>
-            <a:ext cx="10634472" cy="274320"/>
-          </a:xfrm>
-          <a:prstGeom prst="rect">
-            <a:avLst/>
-          </a:prstGeom>
-          <a:noFill/>
-        </p:spPr>
-        <p:txBody>
-          <a:bodyPr wrap="square" lIns="0" tIns="0" rIns="0" bIns="0" anchor="t">
-            <a:spAutoFit/>
-          </a:bodyPr>
-          <a:lstStyle/>
-          <a:p>
-            <a:pPr algn="ctr">
-              <a:lnSpc>
-                <a:spcPct val="105000"/>
-              </a:lnSpc>
-              <a:spcAft>
-                <a:spcPts val="0"/>
-              </a:spcAft>
-              <a:defRPr sz="1000" b="0">
-                <a:solidFill>
-                  <a:srgbClr val="6B7280"/>
-                </a:solidFill>
-                <a:latin typeface="Arial"/>
-              </a:defRPr>
-            </a:pPr>
-            <a:r>
-              <a:rPr sz="1000" b="0">
-                <a:solidFill>
-                  <a:srgbClr val="6B7280"/>
-                </a:solidFill>
-                <a:latin typeface="Arial"/>
-              </a:rPr>
-              <a:t>React SPA → Nginx/Vite proxy → Spring Boot REST API → MySQL</a:t>
-            </a:r>
-          </a:p>
-        </p:txBody>
-      </p:sp>
       <p:pic>
         <p:nvPicPr>
-          <p:cNvPr id="13" name="Picture 12">
-            <a:extLst>
-              <a:ext uri="{FF2B5EF4-FFF2-40B4-BE49-F238E27FC236}">
-                <a16:creationId xmlns:a16="http://schemas.microsoft.com/office/drawing/2014/main" id="{4A296E29-7658-2CFC-3C12-151A483783CA}"/>
-              </a:ext>
-            </a:extLst>
-          </p:cNvPr>
+          <p:cNvPr id="10" name="Picture 9" descr="architecture-diagram.png"/>
           <p:cNvPicPr>
             <a:picLocks noChangeAspect="1"/>
           </p:cNvPicPr>
@@ -28608,14 +27602,62 @@
         </p:blipFill>
         <p:spPr>
           <a:xfrm>
-            <a:off x="918412" y="1732360"/>
-            <a:ext cx="10352127" cy="3982640"/>
+            <a:off x="777240" y="1831874"/>
+            <a:ext cx="10634472" cy="3697172"/>
           </a:xfrm>
           <a:prstGeom prst="rect">
             <a:avLst/>
           </a:prstGeom>
         </p:spPr>
       </p:pic>
+      <p:sp>
+        <p:nvSpPr>
+          <p:cNvPr id="11" name="TextBox 10"/>
+          <p:cNvSpPr txBox="1"/>
+          <p:nvPr/>
+        </p:nvSpPr>
+        <p:spPr>
+          <a:xfrm>
+            <a:off x="777240" y="5852160"/>
+            <a:ext cx="10634472" cy="274320"/>
+          </a:xfrm>
+          <a:prstGeom prst="rect">
+            <a:avLst/>
+          </a:prstGeom>
+          <a:noFill/>
+        </p:spPr>
+        <p:txBody>
+          <a:bodyPr wrap="square" lIns="0" tIns="0" rIns="0" bIns="0" anchor="t">
+            <a:spAutoFit/>
+          </a:bodyPr>
+          <a:lstStyle/>
+          <a:p>
+            <a:pPr algn="ctr">
+              <a:lnSpc>
+                <a:spcPct val="105000"/>
+              </a:lnSpc>
+              <a:spcAft>
+                <a:spcPts val="0"/>
+              </a:spcAft>
+              <a:defRPr sz="1000" b="0">
+                <a:solidFill>
+                  <a:srgbClr val="6B7280"/>
+                </a:solidFill>
+                <a:latin typeface="Arial"/>
+              </a:defRPr>
+            </a:pPr>
+            <a:r>
+              <a:rPr sz="1000" b="0">
+                <a:solidFill>
+                  <a:srgbClr val="6B7280"/>
+                </a:solidFill>
+                <a:latin typeface="Arial"/>
+              </a:rPr>
+              <a:t>React SPA → Nginx/Vite proxy → Spring Boot REST API → MySQL</a:t>
+            </a:r>
+          </a:p>
+        </p:txBody>
+      </p:sp>
     </p:spTree>
   </p:cSld>
   <p:clrMapOvr>
@@ -28971,7 +28013,7 @@
                 </a:solidFill>
                 <a:latin typeface="Arial"/>
               </a:rPr>
-              <a:t>8</a:t>
+              <a:t>7</a:t>
             </a:r>
           </a:p>
         </p:txBody>
@@ -28993,11 +28035,11 @@
             </a:avLst>
           </a:prstGeom>
           <a:solidFill>
-            <a:srgbClr val="FFFFFF"/>
+            <a:srgbClr val="E8EDF4"/>
           </a:solidFill>
-          <a:ln w="12700">
+          <a:ln w="17780">
             <a:solidFill>
-              <a:srgbClr val="D9E2EC"/>
+              <a:srgbClr val="B0BEC5"/>
             </a:solidFill>
           </a:ln>
           <a:effectLst/>
@@ -29452,7 +28494,7 @@
                 </a:solidFill>
                 <a:latin typeface="Arial"/>
               </a:rPr>
-              <a:t>9</a:t>
+              <a:t>8</a:t>
             </a:r>
           </a:p>
         </p:txBody>
@@ -30536,7 +29578,7 @@
                 </a:solidFill>
                 <a:latin typeface="Arial"/>
               </a:rPr>
-              <a:t>10</a:t>
+              <a:t>9</a:t>
             </a:r>
           </a:p>
         </p:txBody>
@@ -30558,11 +29600,11 @@
             </a:avLst>
           </a:prstGeom>
           <a:solidFill>
-            <a:srgbClr val="FFFFFF"/>
+            <a:srgbClr val="E8EDF4"/>
           </a:solidFill>
-          <a:ln w="12700">
+          <a:ln w="17780">
             <a:solidFill>
-              <a:srgbClr val="D9E2EC"/>
+              <a:srgbClr val="B0BEC5"/>
             </a:solidFill>
           </a:ln>
           <a:effectLst/>

</xml_diff>

<commit_message>
update test coverage in docs
</commit_message>
<xml_diff>
--- a/Task 9/Presentation/DoVeSo_BaoCao_Lab3.pptx
+++ b/Task 9/Presentation/DoVeSo_BaoCao_Lab3.pptx
@@ -14714,7 +14714,7 @@
         <p:spPr>
           <a:xfrm>
             <a:off x="1005840" y="2203704"/>
-            <a:ext cx="4800600" cy="3730752"/>
+            <a:ext cx="4800600" cy="1753044"/>
           </a:xfrm>
           <a:prstGeom prst="rect">
             <a:avLst/>
@@ -14742,13 +14742,297 @@
               </a:defRPr>
             </a:pPr>
             <a:r>
-              <a:rPr sz="1300" b="0">
-                <a:solidFill>
-                  <a:srgbClr val="1F2937"/>
-                </a:solidFill>
-                <a:latin typeface="Arial"/>
-              </a:rPr>
-              <a:t>•  Chưa hoàn thành: Google AdSense (FR 1.7), gamification comments (FR 2.6), preview vé dò (FR 3.15).</a:t>
+              <a:rPr sz="1300" b="0" dirty="0">
+                <a:solidFill>
+                  <a:srgbClr val="1F2937"/>
+                </a:solidFill>
+                <a:latin typeface="Arial"/>
+              </a:rPr>
+              <a:t>•  </a:t>
+            </a:r>
+            <a:r>
+              <a:rPr sz="1300" b="0" dirty="0" err="1">
+                <a:solidFill>
+                  <a:srgbClr val="1F2937"/>
+                </a:solidFill>
+                <a:latin typeface="Arial"/>
+              </a:rPr>
+              <a:t>Chưa</a:t>
+            </a:r>
+            <a:r>
+              <a:rPr sz="1300" b="0" dirty="0">
+                <a:solidFill>
+                  <a:srgbClr val="1F2937"/>
+                </a:solidFill>
+                <a:latin typeface="Arial"/>
+              </a:rPr>
+              <a:t> </a:t>
+            </a:r>
+            <a:r>
+              <a:rPr sz="1300" b="0" dirty="0" err="1">
+                <a:solidFill>
+                  <a:srgbClr val="1F2937"/>
+                </a:solidFill>
+                <a:latin typeface="Arial"/>
+              </a:rPr>
+              <a:t>hoàn</a:t>
+            </a:r>
+            <a:r>
+              <a:rPr sz="1300" b="0" dirty="0">
+                <a:solidFill>
+                  <a:srgbClr val="1F2937"/>
+                </a:solidFill>
+                <a:latin typeface="Arial"/>
+              </a:rPr>
+              <a:t> </a:t>
+            </a:r>
+            <a:r>
+              <a:rPr sz="1300" b="0" dirty="0" err="1">
+                <a:solidFill>
+                  <a:srgbClr val="1F2937"/>
+                </a:solidFill>
+                <a:latin typeface="Arial"/>
+              </a:rPr>
+              <a:t>thành</a:t>
+            </a:r>
+            <a:r>
+              <a:rPr sz="1300" b="0" dirty="0">
+                <a:solidFill>
+                  <a:srgbClr val="1F2937"/>
+                </a:solidFill>
+                <a:latin typeface="Arial"/>
+              </a:rPr>
+              <a:t>: Google AdSense (FR 1.7), gamification comments (FR 2.6), preview </a:t>
+            </a:r>
+            <a:r>
+              <a:rPr sz="1300" b="0" dirty="0" err="1">
+                <a:solidFill>
+                  <a:srgbClr val="1F2937"/>
+                </a:solidFill>
+                <a:latin typeface="Arial"/>
+              </a:rPr>
+              <a:t>vé</a:t>
+            </a:r>
+            <a:r>
+              <a:rPr sz="1300" b="0" dirty="0">
+                <a:solidFill>
+                  <a:srgbClr val="1F2937"/>
+                </a:solidFill>
+                <a:latin typeface="Arial"/>
+              </a:rPr>
+              <a:t> </a:t>
+            </a:r>
+            <a:r>
+              <a:rPr sz="1300" b="0" dirty="0" err="1">
+                <a:solidFill>
+                  <a:srgbClr val="1F2937"/>
+                </a:solidFill>
+                <a:latin typeface="Arial"/>
+              </a:rPr>
+              <a:t>dò</a:t>
+            </a:r>
+            <a:r>
+              <a:rPr sz="1300" b="0" dirty="0">
+                <a:solidFill>
+                  <a:srgbClr val="1F2937"/>
+                </a:solidFill>
+                <a:latin typeface="Arial"/>
+              </a:rPr>
+              <a:t> (FR 3.15).</a:t>
+            </a:r>
+          </a:p>
+          <a:p>
+            <a:pPr>
+              <a:lnSpc>
+                <a:spcPct val="108000"/>
+              </a:lnSpc>
+              <a:spcAft>
+                <a:spcPts val="500"/>
+              </a:spcAft>
+              <a:defRPr sz="1300" b="0">
+                <a:solidFill>
+                  <a:srgbClr val="1F2937"/>
+                </a:solidFill>
+                <a:latin typeface="Arial"/>
+              </a:defRPr>
+            </a:pPr>
+            <a:r>
+              <a:rPr sz="1300" b="0" dirty="0">
+                <a:solidFill>
+                  <a:srgbClr val="1F2937"/>
+                </a:solidFill>
+                <a:latin typeface="Arial"/>
+              </a:rPr>
+              <a:t>•  </a:t>
+            </a:r>
+            <a:r>
+              <a:rPr lang="en-US" sz="1300" dirty="0"/>
+              <a:t>Code coverage 70.66%. </a:t>
+            </a:r>
+            <a:r>
+              <a:rPr lang="en-US" sz="1300" dirty="0" err="1"/>
+              <a:t>Phần</a:t>
+            </a:r>
+            <a:r>
+              <a:rPr lang="en-US" sz="1300" dirty="0"/>
+              <a:t> </a:t>
+            </a:r>
+            <a:r>
+              <a:rPr lang="en-US" sz="1300" dirty="0" err="1"/>
+              <a:t>chưa</a:t>
+            </a:r>
+            <a:r>
+              <a:rPr lang="en-US" sz="1300" dirty="0"/>
+              <a:t> </a:t>
+            </a:r>
+            <a:r>
+              <a:rPr lang="en-US" sz="1300" dirty="0" err="1"/>
+              <a:t>phủ</a:t>
+            </a:r>
+            <a:r>
+              <a:rPr lang="en-US" sz="1300" dirty="0"/>
+              <a:t>: </a:t>
+            </a:r>
+            <a:r>
+              <a:rPr lang="en-US" sz="1300" dirty="0" err="1"/>
+              <a:t>các</a:t>
+            </a:r>
+            <a:r>
+              <a:rPr lang="en-US" sz="1300" dirty="0"/>
+              <a:t> </a:t>
+            </a:r>
+            <a:r>
+              <a:rPr lang="en-US" sz="1300" dirty="0" err="1"/>
+              <a:t>lớp</a:t>
+            </a:r>
+            <a:r>
+              <a:rPr lang="en-US" sz="1300" dirty="0"/>
+              <a:t> infra </a:t>
+            </a:r>
+            <a:r>
+              <a:rPr lang="en-US" sz="1300" dirty="0" err="1"/>
+              <a:t>mỏng</a:t>
+            </a:r>
+            <a:r>
+              <a:rPr lang="en-US" sz="1300" dirty="0"/>
+              <a:t> (</a:t>
+            </a:r>
+            <a:r>
+              <a:rPr lang="en-US" sz="1300" dirty="0" err="1"/>
+              <a:t>JwtService</a:t>
+            </a:r>
+            <a:r>
+              <a:rPr lang="en-US" sz="1300" dirty="0"/>
+              <a:t>, config) </a:t>
+            </a:r>
+            <a:r>
+              <a:rPr lang="en-US" sz="1300" dirty="0" err="1"/>
+              <a:t>và</a:t>
+            </a:r>
+            <a:r>
+              <a:rPr lang="en-US" sz="1300" dirty="0"/>
+              <a:t> </a:t>
+            </a:r>
+            <a:r>
+              <a:rPr lang="en-US" sz="1300" dirty="0" err="1"/>
+              <a:t>một</a:t>
+            </a:r>
+            <a:r>
+              <a:rPr lang="en-US" sz="1300" dirty="0"/>
+              <a:t> </a:t>
+            </a:r>
+            <a:r>
+              <a:rPr lang="en-US" sz="1300" dirty="0" err="1"/>
+              <a:t>số</a:t>
+            </a:r>
+            <a:r>
+              <a:rPr lang="en-US" sz="1300" dirty="0"/>
+              <a:t> </a:t>
+            </a:r>
+            <a:r>
+              <a:rPr lang="en-US" sz="1300" dirty="0" err="1"/>
+              <a:t>nhánh</a:t>
+            </a:r>
+            <a:r>
+              <a:rPr lang="en-US" sz="1300" dirty="0"/>
+              <a:t> </a:t>
+            </a:r>
+            <a:r>
+              <a:rPr lang="en-US" sz="1300" dirty="0" err="1"/>
+              <a:t>lỗi</a:t>
+            </a:r>
+            <a:r>
+              <a:rPr lang="en-US" sz="1300" dirty="0"/>
+              <a:t> </a:t>
+            </a:r>
+            <a:r>
+              <a:rPr lang="en-US" sz="1300" dirty="0" err="1"/>
+              <a:t>hiếm</a:t>
+            </a:r>
+            <a:r>
+              <a:rPr lang="en-US" sz="1300" dirty="0"/>
+              <a:t>.</a:t>
+            </a:r>
+          </a:p>
+          <a:p>
+            <a:pPr>
+              <a:lnSpc>
+                <a:spcPct val="108000"/>
+              </a:lnSpc>
+              <a:spcAft>
+                <a:spcPts val="500"/>
+              </a:spcAft>
+              <a:defRPr sz="1300" b="0">
+                <a:solidFill>
+                  <a:srgbClr val="1F2937"/>
+                </a:solidFill>
+                <a:latin typeface="Arial"/>
+              </a:defRPr>
+            </a:pPr>
+            <a:r>
+              <a:rPr sz="1300" b="0" dirty="0">
+                <a:solidFill>
+                  <a:srgbClr val="1F2937"/>
+                </a:solidFill>
+                <a:latin typeface="Arial"/>
+              </a:rPr>
+              <a:t>•  </a:t>
+            </a:r>
+            <a:r>
+              <a:rPr sz="1300" b="0" dirty="0" err="1">
+                <a:solidFill>
+                  <a:srgbClr val="1F2937"/>
+                </a:solidFill>
+                <a:latin typeface="Arial"/>
+              </a:rPr>
+              <a:t>Chưa</a:t>
+            </a:r>
+            <a:r>
+              <a:rPr sz="1300" b="0" dirty="0">
+                <a:solidFill>
+                  <a:srgbClr val="1F2937"/>
+                </a:solidFill>
+                <a:latin typeface="Arial"/>
+              </a:rPr>
+              <a:t> </a:t>
+            </a:r>
+            <a:r>
+              <a:rPr sz="1300" b="0" dirty="0" err="1">
+                <a:solidFill>
+                  <a:srgbClr val="1F2937"/>
+                </a:solidFill>
+                <a:latin typeface="Arial"/>
+              </a:rPr>
+              <a:t>có</a:t>
+            </a:r>
+            <a:r>
+              <a:rPr sz="1300" b="0" dirty="0">
+                <a:solidFill>
+                  <a:srgbClr val="1F2937"/>
+                </a:solidFill>
+                <a:latin typeface="Arial"/>
+              </a:rPr>
+              <a:t> refresh token.</a:t>
             </a:r>
           </a:p>
           <a:p>
@@ -14767,13 +15051,67 @@
               </a:defRPr>
             </a:pPr>
             <a:r>
-              <a:rPr sz="1300" b="0">
-                <a:solidFill>
-                  <a:srgbClr val="1F2937"/>
-                </a:solidFill>
-                <a:latin typeface="Arial"/>
-              </a:rPr>
-              <a:t>•  Code coverage chưa cao, khoảng 37.30%.</a:t>
+              <a:rPr sz="1300" b="0" dirty="0">
+                <a:solidFill>
+                  <a:srgbClr val="1F2937"/>
+                </a:solidFill>
+                <a:latin typeface="Arial"/>
+              </a:rPr>
+              <a:t>•  </a:t>
+            </a:r>
+            <a:r>
+              <a:rPr sz="1300" b="0" dirty="0" err="1">
+                <a:solidFill>
+                  <a:srgbClr val="1F2937"/>
+                </a:solidFill>
+                <a:latin typeface="Arial"/>
+              </a:rPr>
+              <a:t>Chưa</a:t>
+            </a:r>
+            <a:r>
+              <a:rPr sz="1300" b="0" dirty="0">
+                <a:solidFill>
+                  <a:srgbClr val="1F2937"/>
+                </a:solidFill>
+                <a:latin typeface="Arial"/>
+              </a:rPr>
+              <a:t> </a:t>
+            </a:r>
+            <a:r>
+              <a:rPr sz="1300" b="0" dirty="0" err="1">
+                <a:solidFill>
+                  <a:srgbClr val="1F2937"/>
+                </a:solidFill>
+                <a:latin typeface="Arial"/>
+              </a:rPr>
+              <a:t>có</a:t>
+            </a:r>
+            <a:r>
+              <a:rPr sz="1300" b="0" dirty="0">
+                <a:solidFill>
+                  <a:srgbClr val="1F2937"/>
+                </a:solidFill>
+                <a:latin typeface="Arial"/>
+              </a:rPr>
+              <a:t> rate limiting </a:t>
+            </a:r>
+            <a:r>
+              <a:rPr sz="1300" b="0" dirty="0" err="1">
+                <a:solidFill>
+                  <a:srgbClr val="1F2937"/>
+                </a:solidFill>
+                <a:latin typeface="Arial"/>
+              </a:rPr>
+              <a:t>hoặc</a:t>
+            </a:r>
+            <a:r>
+              <a:rPr sz="1300" b="0" dirty="0">
+                <a:solidFill>
+                  <a:srgbClr val="1F2937"/>
+                </a:solidFill>
+                <a:latin typeface="Arial"/>
+              </a:rPr>
+              <a:t> CAPTCHA.</a:t>
             </a:r>
           </a:p>
           <a:p>
@@ -14792,88 +15130,193 @@
               </a:defRPr>
             </a:pPr>
             <a:r>
-              <a:rPr sz="1300" b="0">
-                <a:solidFill>
-                  <a:srgbClr val="1F2937"/>
-                </a:solidFill>
-                <a:latin typeface="Arial"/>
-              </a:rPr>
-              <a:t>•  Chưa có refresh token.</a:t>
-            </a:r>
-          </a:p>
-          <a:p>
-            <a:pPr algn="l">
-              <a:lnSpc>
-                <a:spcPct val="108000"/>
-              </a:lnSpc>
-              <a:spcAft>
-                <a:spcPts val="500"/>
-              </a:spcAft>
-              <a:defRPr sz="1300" b="0">
-                <a:solidFill>
-                  <a:srgbClr val="1F2937"/>
-                </a:solidFill>
-                <a:latin typeface="Arial"/>
-              </a:defRPr>
-            </a:pPr>
-            <a:r>
-              <a:rPr sz="1300" b="0">
-                <a:solidFill>
-                  <a:srgbClr val="1F2937"/>
-                </a:solidFill>
-                <a:latin typeface="Arial"/>
-              </a:rPr>
-              <a:t>•  Chưa có rate limiting hoặc CAPTCHA.</a:t>
-            </a:r>
-          </a:p>
-          <a:p>
-            <a:pPr algn="l">
-              <a:lnSpc>
-                <a:spcPct val="108000"/>
-              </a:lnSpc>
-              <a:spcAft>
-                <a:spcPts val="500"/>
-              </a:spcAft>
-              <a:defRPr sz="1300" b="0">
-                <a:solidFill>
-                  <a:srgbClr val="1F2937"/>
-                </a:solidFill>
-                <a:latin typeface="Arial"/>
-              </a:defRPr>
-            </a:pPr>
-            <a:r>
-              <a:rPr sz="1300" b="0">
-                <a:solidFill>
-                  <a:srgbClr val="1F2937"/>
-                </a:solidFill>
-                <a:latin typeface="Arial"/>
-              </a:rPr>
-              <a:t>•  Dữ liệu kết quả đang nhập tay, chưa crawl tự động.</a:t>
-            </a:r>
-          </a:p>
-          <a:p>
-            <a:pPr algn="l">
-              <a:lnSpc>
-                <a:spcPct val="108000"/>
-              </a:lnSpc>
-              <a:spcAft>
-                <a:spcPts val="500"/>
-              </a:spcAft>
-              <a:defRPr sz="1300" b="0">
-                <a:solidFill>
-                  <a:srgbClr val="1F2937"/>
-                </a:solidFill>
-                <a:latin typeface="Arial"/>
-              </a:defRPr>
-            </a:pPr>
-            <a:r>
-              <a:rPr sz="1300" b="0">
-                <a:solidFill>
-                  <a:srgbClr val="1F2937"/>
-                </a:solidFill>
-                <a:latin typeface="Arial"/>
-              </a:rPr>
-              <a:t>•  Desktop history sort còn hạn chế so với mobile.</a:t>
+              <a:rPr sz="1300" b="0" dirty="0">
+                <a:solidFill>
+                  <a:srgbClr val="1F2937"/>
+                </a:solidFill>
+                <a:latin typeface="Arial"/>
+              </a:rPr>
+              <a:t>•  </a:t>
+            </a:r>
+            <a:r>
+              <a:rPr sz="1300" b="0" dirty="0" err="1">
+                <a:solidFill>
+                  <a:srgbClr val="1F2937"/>
+                </a:solidFill>
+                <a:latin typeface="Arial"/>
+              </a:rPr>
+              <a:t>Dữ</a:t>
+            </a:r>
+            <a:r>
+              <a:rPr sz="1300" b="0" dirty="0">
+                <a:solidFill>
+                  <a:srgbClr val="1F2937"/>
+                </a:solidFill>
+                <a:latin typeface="Arial"/>
+              </a:rPr>
+              <a:t> </a:t>
+            </a:r>
+            <a:r>
+              <a:rPr sz="1300" b="0" dirty="0" err="1">
+                <a:solidFill>
+                  <a:srgbClr val="1F2937"/>
+                </a:solidFill>
+                <a:latin typeface="Arial"/>
+              </a:rPr>
+              <a:t>liệu</a:t>
+            </a:r>
+            <a:r>
+              <a:rPr sz="1300" b="0" dirty="0">
+                <a:solidFill>
+                  <a:srgbClr val="1F2937"/>
+                </a:solidFill>
+                <a:latin typeface="Arial"/>
+              </a:rPr>
+              <a:t> </a:t>
+            </a:r>
+            <a:r>
+              <a:rPr sz="1300" b="0" dirty="0" err="1">
+                <a:solidFill>
+                  <a:srgbClr val="1F2937"/>
+                </a:solidFill>
+                <a:latin typeface="Arial"/>
+              </a:rPr>
+              <a:t>kết</a:t>
+            </a:r>
+            <a:r>
+              <a:rPr sz="1300" b="0" dirty="0">
+                <a:solidFill>
+                  <a:srgbClr val="1F2937"/>
+                </a:solidFill>
+                <a:latin typeface="Arial"/>
+              </a:rPr>
+              <a:t> </a:t>
+            </a:r>
+            <a:r>
+              <a:rPr sz="1300" b="0" dirty="0" err="1">
+                <a:solidFill>
+                  <a:srgbClr val="1F2937"/>
+                </a:solidFill>
+                <a:latin typeface="Arial"/>
+              </a:rPr>
+              <a:t>quả</a:t>
+            </a:r>
+            <a:r>
+              <a:rPr sz="1300" b="0" dirty="0">
+                <a:solidFill>
+                  <a:srgbClr val="1F2937"/>
+                </a:solidFill>
+                <a:latin typeface="Arial"/>
+              </a:rPr>
+              <a:t> </a:t>
+            </a:r>
+            <a:r>
+              <a:rPr sz="1300" b="0" dirty="0" err="1">
+                <a:solidFill>
+                  <a:srgbClr val="1F2937"/>
+                </a:solidFill>
+                <a:latin typeface="Arial"/>
+              </a:rPr>
+              <a:t>đang</a:t>
+            </a:r>
+            <a:r>
+              <a:rPr sz="1300" b="0" dirty="0">
+                <a:solidFill>
+                  <a:srgbClr val="1F2937"/>
+                </a:solidFill>
+                <a:latin typeface="Arial"/>
+              </a:rPr>
+              <a:t> </a:t>
+            </a:r>
+            <a:r>
+              <a:rPr sz="1300" b="0" dirty="0" err="1">
+                <a:solidFill>
+                  <a:srgbClr val="1F2937"/>
+                </a:solidFill>
+                <a:latin typeface="Arial"/>
+              </a:rPr>
+              <a:t>nhập</a:t>
+            </a:r>
+            <a:r>
+              <a:rPr sz="1300" b="0" dirty="0">
+                <a:solidFill>
+                  <a:srgbClr val="1F2937"/>
+                </a:solidFill>
+                <a:latin typeface="Arial"/>
+              </a:rPr>
+              <a:t> </a:t>
+            </a:r>
+            <a:r>
+              <a:rPr sz="1300" b="0" dirty="0" err="1">
+                <a:solidFill>
+                  <a:srgbClr val="1F2937"/>
+                </a:solidFill>
+                <a:latin typeface="Arial"/>
+              </a:rPr>
+              <a:t>tay</a:t>
+            </a:r>
+            <a:r>
+              <a:rPr sz="1300" b="0" dirty="0">
+                <a:solidFill>
+                  <a:srgbClr val="1F2937"/>
+                </a:solidFill>
+                <a:latin typeface="Arial"/>
+              </a:rPr>
+              <a:t>, </a:t>
+            </a:r>
+            <a:r>
+              <a:rPr sz="1300" b="0" dirty="0" err="1">
+                <a:solidFill>
+                  <a:srgbClr val="1F2937"/>
+                </a:solidFill>
+                <a:latin typeface="Arial"/>
+              </a:rPr>
+              <a:t>chưa</a:t>
+            </a:r>
+            <a:r>
+              <a:rPr sz="1300" b="0" dirty="0">
+                <a:solidFill>
+                  <a:srgbClr val="1F2937"/>
+                </a:solidFill>
+                <a:latin typeface="Arial"/>
+              </a:rPr>
+              <a:t> crawl </a:t>
+            </a:r>
+            <a:r>
+              <a:rPr sz="1300" b="0" dirty="0" err="1">
+                <a:solidFill>
+                  <a:srgbClr val="1F2937"/>
+                </a:solidFill>
+                <a:latin typeface="Arial"/>
+              </a:rPr>
+              <a:t>tự</a:t>
+            </a:r>
+            <a:r>
+              <a:rPr sz="1300" b="0" dirty="0">
+                <a:solidFill>
+                  <a:srgbClr val="1F2937"/>
+                </a:solidFill>
+                <a:latin typeface="Arial"/>
+              </a:rPr>
+              <a:t> </a:t>
+            </a:r>
+            <a:r>
+              <a:rPr sz="1300" b="0" dirty="0" err="1">
+                <a:solidFill>
+                  <a:srgbClr val="1F2937"/>
+                </a:solidFill>
+                <a:latin typeface="Arial"/>
+              </a:rPr>
+              <a:t>động</a:t>
+            </a:r>
+            <a:r>
+              <a:rPr sz="1300" b="0" dirty="0">
+                <a:solidFill>
+                  <a:srgbClr val="1F2937"/>
+                </a:solidFill>
+                <a:latin typeface="Arial"/>
+              </a:rPr>
+              <a:t>.</a:t>
             </a:r>
           </a:p>
         </p:txBody>
@@ -25279,7 +25722,7 @@
               </a:defRPr>
             </a:pPr>
             <a:r>
-              <a:rPr sz="1200" b="0">
+              <a:rPr sz="1200" b="0" dirty="0">
                 <a:solidFill>
                   <a:srgbClr val="1F2937"/>
                 </a:solidFill>
@@ -25304,7 +25747,7 @@
               </a:defRPr>
             </a:pPr>
             <a:r>
-              <a:rPr sz="1200" b="0">
+              <a:rPr sz="1200" b="0" dirty="0">
                 <a:solidFill>
                   <a:srgbClr val="1F2937"/>
                 </a:solidFill>
@@ -25329,7 +25772,7 @@
               </a:defRPr>
             </a:pPr>
             <a:r>
-              <a:rPr sz="1200" b="0">
+              <a:rPr sz="1200" b="0" dirty="0">
                 <a:solidFill>
                   <a:srgbClr val="1F2937"/>
                 </a:solidFill>
@@ -25354,7 +25797,7 @@
               </a:defRPr>
             </a:pPr>
             <a:r>
-              <a:rPr sz="1200" b="0">
+              <a:rPr sz="1200" b="0" dirty="0">
                 <a:solidFill>
                   <a:srgbClr val="1F2937"/>
                 </a:solidFill>
@@ -25379,7 +25822,7 @@
               </a:defRPr>
             </a:pPr>
             <a:r>
-              <a:rPr sz="1200" b="0">
+              <a:rPr sz="1200" b="0" dirty="0">
                 <a:solidFill>
                   <a:srgbClr val="1F2937"/>
                 </a:solidFill>
@@ -25404,7 +25847,7 @@
               </a:defRPr>
             </a:pPr>
             <a:r>
-              <a:rPr sz="1200" b="0">
+              <a:rPr sz="1200" b="0" dirty="0">
                 <a:solidFill>
                   <a:srgbClr val="1F2937"/>
                 </a:solidFill>
@@ -25429,7 +25872,7 @@
               </a:defRPr>
             </a:pPr>
             <a:r>
-              <a:rPr sz="1200" b="0">
+              <a:rPr sz="1200" b="0" dirty="0">
                 <a:solidFill>
                   <a:srgbClr val="1F2937"/>
                 </a:solidFill>

</xml_diff>